<commit_message>
Sync deck speaker-note section references with renumbered study
The sixfold-grammar split shifted study §§7.4-7.7 to §§7.5-7.8; updates the affected [Sources] blocks in the deck notes pane (slides 17-20, 24) and regenerates the slides and read-aloud notes PDFs in order.

Co-authored-by: Raghava Mohan Madhwapathi <raghavamohan@users.noreply.github.com>
</commit_message>
<xml_diff>
--- a/Studies/A-State-Dynamic-Model-Of-Coexistence/A-State-Dynamic-Model-Of-Coexistence-Madhyasth-Darshan.pptx
+++ b/Studies/A-State-Dynamic-Model-Of-Coexistence/A-State-Dynamic-Model-Of-Coexistence-Madhyasth-Darshan.pptx
@@ -1230,7 +1230,7 @@
           </a:p>
           <a:p>
             <a:r>
-              <a:t>- Study §7.5</a:t>
+              <a:t>- Study §7.6</a:t>
             </a:r>
           </a:p>
           <a:p>
@@ -1316,7 +1316,7 @@
           </a:p>
           <a:p>
             <a:r>
-              <a:t>- Study §§7.2–7.4, 8.4</a:t>
+              <a:t>- Study §§7.2–7.5, 8.4</a:t>
             </a:r>
           </a:p>
           <a:p>
@@ -1402,7 +1402,7 @@
           </a:p>
           <a:p>
             <a:r>
-              <a:t>- Study §§7.1, 7.4, 7.6</a:t>
+              <a:t>- Study §§7.1, 7.5, 7.7</a:t>
             </a:r>
           </a:p>
           <a:p>
@@ -1574,7 +1574,7 @@
           </a:p>
           <a:p>
             <a:r>
-              <a:t>- Study §§7.7, 10.3</a:t>
+              <a:t>- Study §§7.8, 10.3</a:t>
             </a:r>
           </a:p>
           <a:p>
@@ -1918,7 +1918,7 @@
           </a:p>
           <a:p>
             <a:r>
-              <a:t>- Study §§7.3, 8.3, 11.2</a:t>
+              <a:t>- Study §§7.4, 8.3, 11.2</a:t>
             </a:r>
           </a:p>
           <a:p>

</xml_diff>

<commit_message>
Integrate Jeevan, values and awakened tradition into state-dynamic synthesis
</commit_message>
<xml_diff>
--- a/Studies/A-State-Dynamic-Model-Of-Coexistence/A-State-Dynamic-Model-Of-Coexistence-Madhyasth-Darshan.pptx
+++ b/Studies/A-State-Dynamic-Model-Of-Coexistence/A-State-Dynamic-Model-Of-Coexistence-Madhyasth-Darshan.pptx
@@ -531,10 +531,14 @@
           <a:lstStyle/>
           <a:p>
             <a:r>
-              <a:t>Welcome. This session walks through the study “From Unit Activity to Human Orderliness: A State-Dynamic Reconstruction of Coexistence.” The study retells, in one connected sequence, what the primary texts say about existence: how every unit is already active, how structures form, where jeevan comes from, what changes at the human threshold, and what humans must understand and establish. The study also contains a formal appendix; we will not touch that mathematics today. Everything in this deck is the prose story, told for practitioners of Madhyasth Darshan — with the page references kept on every slide so you can return to the texts themselves.</a:t>
-            </a:r>
-          </a:p>
-          <a:p/>
+              <a:t>This session connects the activity of units with the architecture of jeevan and the purpose of human living. We begin with coexistence and the four aspects of an active unit. We then examine constitutional completeness, the human body association, and the five integrated faculties. Understanding makes correct evaluation and just fulfilment possible. Its highest fulfilment is paramanand, the continuity of realisation in coexistence. Humane conduct gives that understanding a public expression, and education with shared arrangements sustains an awakened tradition. The full study develops the argument and its formal account in the appendices.</a:t>
+            </a:r>
+          </a:p>
+          <a:p>
+            <a:r>
+              <a:t/>
+            </a:r>
+          </a:p>
           <a:p>
             <a:r>
               <a:t>[Sources]</a:t>
@@ -542,12 +546,12 @@
           </a:p>
           <a:p>
             <a:r>
-              <a:t>- A State-Dynamic Model of Coexistence — opening summary and §§1–11</a:t>
-            </a:r>
-          </a:p>
-          <a:p>
-            <a:r>
-              <a:t>- MVD; SB; JV; KD (tr. Rakesh Gupta; KD working translation)</a:t>
+              <a:t>- Study §§1–11 and Conclusion</a:t>
+            </a:r>
+          </a:p>
+          <a:p>
+            <a:r>
+              <a:t>- MVD pp.78,94,174,315,327; JV printed pp.60–61</a:t>
             </a:r>
           </a:p>
         </p:txBody>
@@ -617,10 +621,14 @@
           <a:lstStyle/>
           <a:p>
             <a:r>
-              <a:t>What is a structure, if a unit is an activity? The compound-versus-mixture contrast answers it. In a mixture nothing closes: each component keeps showing its own conduct. In a compound, complementary activities close a new motion-path — from then on there is one activity, with its own form, property, essential nature, and dharma, and the constituents keep running inside it under conditions the whole now sets. Three consequences repeat at every level: the closure is a genuinely new unit; its constituents persist; and when it disintegrates, nothing is annihilated, because there never was an extra substance — only a motion-path that no longer holds as one.</a:t>
-            </a:r>
-          </a:p>
-          <a:p/>
+              <a:t>A mixture and a compound have different forms of organisation. In the mixture, the components retain their separate public conduct. In the compound, their participation sustains a bounded whole with its own characteristic conduct. The whole and its constituents remain available for description through form, property, essential nature and dharma. Disintegration changes the organisation through which they held together. Their continuing activity makes the result available for further composition and participation.</a:t>
+            </a:r>
+          </a:p>
+          <a:p>
+            <a:r>
+              <a:t/>
+            </a:r>
+          </a:p>
           <a:p>
             <a:r>
               <a:t>[Sources]</a:t>
@@ -628,12 +636,12 @@
           </a:p>
           <a:p>
             <a:r>
-              <a:t>- Study §§4.2, 5.4</a:t>
-            </a:r>
-          </a:p>
-          <a:p>
-            <a:r>
-              <a:t>- MVD p. 42; SB p. 260; KD §§3.1–3.2 pp. 56–60, §3.11 pp. 103–104</a:t>
+              <a:t>- Study §§4.2,5.4,9.3</a:t>
+            </a:r>
+          </a:p>
+          <a:p>
+            <a:r>
+              <a:t>- MVD p.42; SB p.260; KD §§3.1–3.2 pp.56–60, §3.11 pp.103–104</a:t>
             </a:r>
           </a:p>
         </p:txBody>
@@ -703,10 +711,14 @@
           <a:lstStyle/>
           <a:p>
             <a:r>
-              <a:t>Two lines, never one ladder. On the compositional line, closures build upward: atoms into molecules, molecules into compounds and minerals, chemical activity into pranic cells, cells into plant, animal, and human bodies. Everything on this line remains of the order of what composes it. On the atomic line, one developing atom completes its own constitution and becomes jeevan — a change of kind, not a joining. The two lines meet when a body operates with a constitutionally complete jeevan: the animal and human joint forms. That is why the human is not a later animal composition, and why no amount of bodily complexity produces sentience by itself.</a:t>
-            </a:r>
-          </a:p>
-          <a:p/>
+              <a:t>Composition forms material wholes and provides the conditions for pranic bodies. Within this development, nourishment and bodily growth can continue through the activity of an existing body, while reproduction and new structural formation establish further wholes. Atomic development reaches the constitutional completeness of jeevan. A compatible animal or human body provides its medium of embodied participation. Constitutional completeness, bodily formation and human awakening therefore have their own meanings within the connected account of development.</a:t>
+            </a:r>
+          </a:p>
+          <a:p>
+            <a:r>
+              <a:t/>
+            </a:r>
+          </a:p>
           <a:p>
             <a:r>
               <a:t>[Sources]</a:t>
@@ -714,12 +726,12 @@
           </a:p>
           <a:p>
             <a:r>
-              <a:t>- Study §§4.3–4.4, 6</a:t>
-            </a:r>
-          </a:p>
-          <a:p>
-            <a:r>
-              <a:t>- KD §§3.2–3.3 pp. 58–62; SB pp. 75–76; MVD pp. 8, 13</a:t>
+              <a:t>- Study §§4.3–4.5,6</a:t>
+            </a:r>
+          </a:p>
+          <a:p>
+            <a:r>
+              <a:t>- SB pp.60–62,75–76; MVD pp.8,13,91; KD §§3.2–3.3 pp.58–62</a:t>
             </a:r>
           </a:p>
         </p:txBody>
@@ -789,10 +801,14 @@
           <a:lstStyle/>
           <a:p>
             <a:r>
-              <a:t>Constitutional completeness is the threshold between the insentient and the sentient. When a developing atom achieves complete particle balance, its hunger for particles drops to zero — irreversibly. It becomes free of the two structural bondages, molecular and weight, and its strength and power are described as inexhaustible: the immortality of result. In their place stands one new bondage — hope-bondage. Jeevan is not released into indifference: in the animal order that orientation is evidenced as the hope to live; in the human order the dharma-profile is happiness. This is a change in one atom, on its own line — not a composition, and never repeated or reversed.</a:t>
-            </a:r>
-          </a:p>
-          <a:p/>
+              <a:t>Constitutional completeness establishes the enduring sentient unit. The complete atomic constitution becomes free of the molecular and weight bondages associated with structural participation. Its strength and power are inexhaustible, and hope-bondage expresses its sentient orientation. Through an animal body, jeevan participates with the hope to live. Through the human body, its aspiration includes happiness and the opportunity for comprehensive understanding. The constitutional achievement persists through the subsequent development of its understanding and conduct.</a:t>
+            </a:r>
+          </a:p>
+          <a:p>
+            <a:r>
+              <a:t/>
+            </a:r>
+          </a:p>
           <a:p>
             <a:r>
               <a:t>[Sources]</a:t>
@@ -805,7 +821,7 @@
           </a:p>
           <a:p>
             <a:r>
-              <a:t>- MVD pp. 77, 91; SB pp. 55, 61, 92, 144–145; KD §3.3 pp. 60–62</a:t>
+              <a:t>- MVD pp.77,91; SB pp.55,61,92; KD §3.3 pp.60–62</a:t>
             </a:r>
           </a:p>
         </p:txBody>
@@ -875,10 +891,14 @@
           <a:lstStyle/>
           <a:p>
             <a:r>
-              <a:t>Animal and human orders are joint forms: a pranic body and a constitutionally complete jeevan in association. In the animal, jeevan expresses the hope to live through species-conformance — recognition, friendliness and opposition, tasting, selection — with no knowing-and-believing circuit. In the human, the developed body is a richer medium: sensitivity presents through the five senses, and cognisance — jeevan’s knowing-and-accepting capacity — can govern it. The crucial grammar: association, not fusion. Body stays pranic; jeevan stays jeevan. And the association persists in delusion and awakening alike — so a deluded person is not less of a joint form, and awakening does not create the association, it fulfils it.</a:t>
-            </a:r>
-          </a:p>
-          <a:p/>
+              <a:t>Animal and human manifestation each join a pranic body with a constitutionally complete jeevan. The same five-faculty constitution belongs to jeevan in either association. Animal participation has species-conformant recognition, tasting and selection with the hope to live. The developed human bodily medium makes imagination, freedom of action and comprehensive understanding available. Study can develop cognisance until it governs sensitivity. The body and jeevan continue their association while human understanding and conduct are refined.</a:t>
+            </a:r>
+          </a:p>
+          <a:p>
+            <a:r>
+              <a:t/>
+            </a:r>
+          </a:p>
           <a:p>
             <a:r>
               <a:t>[Sources]</a:t>
@@ -886,12 +906,12 @@
           </a:p>
           <a:p>
             <a:r>
-              <a:t>- Study §§6.2–6.4, 7.2</a:t>
-            </a:r>
-          </a:p>
-          <a:p>
-            <a:r>
-              <a:t>- SB pp. 55, 63–64; JV pp. 47–49, 59; KD §3.10 p. 102</a:t>
+              <a:t>- Study §§6.2–6.4,7.2,9.4</a:t>
+            </a:r>
+          </a:p>
+          <a:p>
+            <a:r>
+              <a:t>- SB pp.55,63–64; MVD p.78; JV printed pp.47–49,67–68,72–74</a:t>
             </a:r>
           </a:p>
         </p:txBody>
@@ -961,10 +981,14 @@
           <a:lstStyle/>
           <a:p>
             <a:r>
-              <a:t>This distinction does the most practical work in the study. Three different things get called ‘wholes’. A structural closure — molecule, cell, body — holds by configuration; nobody has to recognise anything. A joint association — an animal or a human — holds as a typed association of body and jeevan. A maintained relational order — a marriage, a family, a work process, an organisation — holds only through human recognition, value-fulfilment, regulation, and evaluation. Treating a family like a compound, or an institution like a being with its own jeevan, is a category mistake. And note the consoling side: your misrecognition does not erase an actual relationship — what fails is its just fulfilment, which can be corrected.</a:t>
-            </a:r>
-          </a:p>
-          <a:p/>
+              <a:t>A structural whole, a body–jeevan association and a maintained human arrangement have different forms of togetherness. In a molecule or body, constituents sustain the whole through their definite participation. In an animal or human being, body and jeevan associate while each retains its constitution. A family, school or shared garden continues through recognised responsibilities, appropriate means and fulfilled work. Correcting a mistaken recognition restores attention to the actual relationship and what it requires.</a:t>
+            </a:r>
+          </a:p>
+          <a:p>
+            <a:r>
+              <a:t/>
+            </a:r>
+          </a:p>
           <a:p>
             <a:r>
               <a:t>[Sources]</a:t>
@@ -972,12 +996,12 @@
           </a:p>
           <a:p>
             <a:r>
-              <a:t>- Study §§3.6, 9.3, 11.1</a:t>
-            </a:r>
-          </a:p>
-          <a:p>
-            <a:r>
-              <a:t>- MVD p. 42; JV pp. 97–98</a:t>
+              <a:t>- Study §§3.6,9.3,11.1</a:t>
+            </a:r>
+          </a:p>
+          <a:p>
+            <a:r>
+              <a:t>- MVD p.42; JV printed pp.97–98</a:t>
             </a:r>
           </a:p>
         </p:txBody>
@@ -1047,10 +1071,14 @@
           <a:lstStyle/>
           <a:p>
             <a:r>
-              <a:t>Movement Three goes inside. The human joint form carries the whole architecture of jeevan: five faculties, ten activities, and the vocabulary they work over. Here the darshan explains delusion — why sincere people err — and awakening: what study, direct recognition, enlightenment, and realisation actually change. Nothing new is added to jeevan by awakening; what changes is which activities are effective and from which direction they are governed.</a:t>
-            </a:r>
-          </a:p>
-          <a:p/>
+              <a:t>The human body association carries the complete architecture of jeevan. Five faculties express ten generic activities, with a detailed vocabulary of understanding and conduct. Human imagination and freedom can organise activity through sensory preference or through a comprehensive understanding of relationship and purpose. Study, direct recognition, enlightenment and realisation develop the content of that understanding. Partial humane participation provides something real to examine and deepen as conduct becomes more dependable.</a:t>
+            </a:r>
+          </a:p>
+          <a:p>
+            <a:r>
+              <a:t/>
+            </a:r>
+          </a:p>
           <a:p>
             <a:r>
               <a:t>[Sources]</a:t>
@@ -1063,7 +1091,7 @@
           </a:p>
           <a:p>
             <a:r>
-              <a:t>- MVD pp. 66–67, 78, 126; JV pp. 73–74, 92–94; KD §3.6</a:t>
+              <a:t>- MVD pp.66–67,78,126; JV printed pp.72–74; MSM printed p.49</a:t>
             </a:r>
           </a:p>
         </p:txBody>
@@ -1133,10 +1161,14 @@
           <a:lstStyle/>
           <a:p>
             <a:r>
-              <a:t>Jeevan’s inner architecture. Five faculties, each with a paired activity: one borne in state as strength, one expressed in motion as power. Mun tastes and selects; vritti compares and analyses; chitta contemplates and images; buddhi is enlightened and resolves; atma realises and evidences. Notice the same state-and-motion grammar we met in the atom — jeevan is a unit, not an exception. In finer grain the texts enumerate sixty-one bal–shakti positions, one hundred and twenty-two named activities, distributed one, two, eight, eighteen, and thirty-two across the faculties: the vocabulary over which these ten work. The values we will meet later — trust, respect, happiness, peace — are named positions in that vocabulary.</a:t>
-            </a:r>
-          </a:p>
-          <a:p/>
+              <a:t>Jeevan has a centre and four orbits. Atma occupies the centre, buddhi the first orbit, chitta the second, vritti the third and mun the fourth. Satta pervades the whole and every constituent. Each faculty has one generic pair: realisation and evidence, enlightenment and resolve, contemplation and imaging, comparison and analysis, tasting and selection. The detailed vocabulary comprises one, two, eight, eighteen and thirty-two pairs at these respective faculties, giving sixty-one pairs and a hundred and twenty-two named activities. Their specific definitions include actual participation. The full inventory belongs to one integrated jeevan, whose realised understanding becomes effective throughout conduct.</a:t>
+            </a:r>
+          </a:p>
+          <a:p>
+            <a:r>
+              <a:t/>
+            </a:r>
+          </a:p>
           <a:p>
             <a:r>
               <a:t>[Sources]</a:t>
@@ -1144,12 +1176,12 @@
           </a:p>
           <a:p>
             <a:r>
-              <a:t>- Study §7.3</a:t>
-            </a:r>
-          </a:p>
-          <a:p>
-            <a:r>
-              <a:t>- KD §3.6 pp. 71–72; JV pp. 92–94; MVD pp. 78, 323, 328–348; AVD pp. 91–94</a:t>
+              <a:t>- Study §7.3 and the concentric architecture companion</a:t>
+            </a:r>
+          </a:p>
+          <a:p>
+            <a:r>
+              <a:t>- MVD pp.78,323,328–348; AVD pp.91–94; KD §3.6 pp.71–72</a:t>
             </a:r>
           </a:p>
         </p:txBody>
@@ -1219,10 +1251,14 @@
           <a:lstStyle/>
           <a:p>
             <a:r>
-              <a:t>Delusion, bhram, is a precise diagnosis, not an insult. When jeevan identifies itself with the body, the upper activities remain unevidenced and comparison is organised from below. Of the ten activities, four and a half are then effective: selection, tasting, analysis, imaging, and half of comparison. The prevailing references become priya, hita, labh — the pleasant, the healthy, the profitable. Human dharma remains happiness even in delusion; what goes wrong is what is accepted as its fulfilment. And note the encouraging structure: the inventory of activities is intact. Awakening does not install new parts — it changes the direction from which tasting and selection are governed.</a:t>
-            </a:r>
-          </a:p>
-          <a:p/>
+              <a:t>In delusion, the body is taken as the self and the pleasant, bodily benefit and gain prevail in evaluation. Four and a half generic activities are effective in this orientation: tasting, selection, analysis, imaging and the sensory half of comparison. All ten activities and all five faculties remain present. A parent can still recognise a need and fulfil care or generosity. Learning examines that real participation and extends its dependable understanding. Tasting can be preference-based, value-based or goal-based. Evaluation can overvalue, undervalue or mistake what is present. Freedom from these distortions develops through correct recognition and humane participation.</a:t>
+            </a:r>
+          </a:p>
+          <a:p>
+            <a:r>
+              <a:t/>
+            </a:r>
+          </a:p>
           <a:p>
             <a:r>
               <a:t>[Sources]</a:t>
@@ -1230,12 +1266,12 @@
           </a:p>
           <a:p>
             <a:r>
-              <a:t>- Study §7.6</a:t>
-            </a:r>
-          </a:p>
-          <a:p>
-            <a:r>
-              <a:t>- JV pp. 73–74; MVD pp. 58, 66–67, 78, 80–81; SB pp. 91–92</a:t>
+              <a:t>- Study §§7.5–7.6</a:t>
+            </a:r>
+          </a:p>
+          <a:p>
+            <a:r>
+              <a:t>- JV printed pp.72–74; MSM printed p.49; PS printed pp.40–41; MVD pp.152–153,306</a:t>
             </a:r>
           </a:p>
         </p:txBody>
@@ -1305,10 +1341,14 @@
           <a:lstStyle/>
           <a:p>
             <a:r>
-              <a:t>How does delusion end? Through study that matures. The texts give the sequence: acceptance in mun, qualitative analysis in vritti, direct recognition — sakshatkar — in chitta, enlightenment — bodh — in buddhi, and then realisation — anubhav — in atma, whose object is truth as coexistence. Once realised, the same content projects outward: resolve, imaging, analysis, selection, conduct. This outward direction is higher-conformance — mun governed from the upper faculties, so tasting and selection become justice-natural, and cognisance governs sensitivity. Two cautions: these are functional dependencies, not a clocked pipeline; and nothing is automatic — study does not force sakshatkar, and dissatisfaction does not force inquiry.</a:t>
-            </a:r>
-          </a:p>
-          <a:p/>
+              <a:t>Study begins with meaning accepted for consideration in mun. Vritti deliberates, chitta directly recognises, buddhi becomes enlightened, and atma realises truth as coexistence. Realised understanding then informs resolve, imaging, analysis and selection in bodily conduct. These directions describe functional relations in the continuously active whole. Practice uses the body and material things alongside hope, thought, desire and resolve as means toward realised participation. A learner examines the meaning, contributes in a relationship, and evaluates the result as understanding develops.</a:t>
+            </a:r>
+          </a:p>
+          <a:p>
+            <a:r>
+              <a:t/>
+            </a:r>
+          </a:p>
           <a:p>
             <a:r>
               <a:t>[Sources]</a:t>
@@ -1316,12 +1356,12 @@
           </a:p>
           <a:p>
             <a:r>
-              <a:t>- Study §§7.2–7.5, 8.4</a:t>
-            </a:r>
-          </a:p>
-          <a:p>
-            <a:r>
-              <a:t>- MVD pp. 97–100, 126, 155–156, 208; JV p. 62</a:t>
+              <a:t>- Study §§7.2–7.5,8.4</a:t>
+            </a:r>
+          </a:p>
+          <a:p>
+            <a:r>
+              <a:t>- MVD pp.97–100,126,155–156,208,322–323; JV printed p.61</a:t>
             </a:r>
           </a:p>
         </p:txBody>
@@ -1391,10 +1431,14 @@
           <a:lstStyle/>
           <a:p>
             <a:r>
-              <a:t>Complete Knowledge — gyan — has three contents: coexistence, jeevan, and humane conduct. All three are enlightened together in buddhi; realisation in atma is of truth as coexistence; and humane conduct additionally demands practised evidence — it cannot stay verbal. The study insists on separating four achievements we usually blur: knowing, believing, recognising, and fulfilling. Each can fail independently. That is why a well-read person can still fail a relationship, and why recognition — not information — is the hinge of justice. Knowledge is never transmitted like a substance: teachers and texts present content, but unfolding happens in the learner’s own jeevan.</a:t>
-            </a:r>
-          </a:p>
-          <a:p/>
+              <a:t>Complete knowledge comprises coexistence, jeevan and humane conduct. Enlightenment in buddhi encompasses all three. Realisation in atma concerns truth as coexistence, and humane conduct evidences its meaning in living. Knowing, believing, recognising and fulfilling are assessed distinctly. A learner may explain a principle yet require help in recognising its application. Someone who recognises a responsibility may need additional means to fulfil it. The teacher offers meaningful content and an example, while the learner develops independent understanding through inquiry and participation.</a:t>
+            </a:r>
+          </a:p>
+          <a:p>
+            <a:r>
+              <a:t/>
+            </a:r>
+          </a:p>
           <a:p>
             <a:r>
               <a:t>[Sources]</a:t>
@@ -1402,12 +1446,12 @@
           </a:p>
           <a:p>
             <a:r>
-              <a:t>- Study §§7.1, 7.5, 7.7</a:t>
-            </a:r>
-          </a:p>
-          <a:p>
-            <a:r>
-              <a:t>- MVD pp. 13, 260, 300; JV pp. 69–70; KD §3.17 pp. 145–148</a:t>
+              <a:t>- Study §§7.1,7.5,7.7</a:t>
+            </a:r>
+          </a:p>
+          <a:p>
+            <a:r>
+              <a:t>- MVD pp.13,260,300; JV printed pp.69–70,165; KD §3.17 pp.145–148</a:t>
             </a:r>
           </a:p>
         </p:txBody>
@@ -1477,10 +1521,14 @@
           <a:lstStyle/>
           <a:p>
             <a:r>
-              <a:t>The study asks six questions in a fixed order, and each answer becomes the ground for the next. First, why activity needs no starter — saturation. Second, how structures hold — closure. Third, where jeevan comes from — constitutional completeness in one atomic line. Fourth, how a living being works — the body–jeevan joint form. Fifth, the human threshold — what nature does not settle for us. Sixth, evidence — how understanding is tested in relationship, work, and society. Keep this ladder in mind; every slide belongs to one of these six steps.</a:t>
-            </a:r>
-          </a:p>
-          <a:p/>
+              <a:t>The argument connects six questions. Saturation grounds the activity of units. Mutual participation sustains material wholes. Constitutional completeness establishes jeevan. Compatible bodies provide the medium for animal and human manifestation. Human imagination and freedom open the possibility of comprehensive understanding and chosen conduct. Evaluation examines how that conduct fulfils its relationships and purpose. Education, humane constitution and continuing practical arrangements then make awakened participation available to further persons and generations.</a:t>
+            </a:r>
+          </a:p>
+          <a:p>
+            <a:r>
+              <a:t/>
+            </a:r>
+          </a:p>
           <a:p>
             <a:r>
               <a:t>[Sources]</a:t>
@@ -1488,12 +1536,12 @@
           </a:p>
           <a:p>
             <a:r>
-              <a:t>- A State-Dynamic Model of Coexistence — opening summary</a:t>
-            </a:r>
-          </a:p>
-          <a:p>
-            <a:r>
-              <a:t>- Study §§1–11 (the six-part main line)</a:t>
+              <a:t>- Study §§1–11</a:t>
+            </a:r>
+          </a:p>
+          <a:p>
+            <a:r>
+              <a:t>- SB pp.19–20,60–62,234–240; MVD pp.19,78,315,321</a:t>
             </a:r>
           </a:p>
         </p:txBody>
@@ -1563,10 +1611,14 @@
           <a:lstStyle/>
           <a:p>
             <a:r>
-              <a:t>Humane conduct is the third content of knowledge, and it has three limbs. Values are recognised and fulfilled in relationship — the texts organise them in five families: object values in things, jeevan values as inner harmonies, human values as essential nature, established values inherent in relationships, and civic values as their expression. Character is evidenced concretely: rightfully owned wealth, marital faithfulness, kindness in work and behaviour. Ethics directs body, mind, and wealth toward right-use, protection, and regeneration. The quoted sentence carries the practical weight: values can be tasted only when relationships are accepted and recognised. Without recognition, mun tastes the pleasant, the healthy, or the profitable instead — and calls it living.</a:t>
-            </a:r>
-          </a:p>
-          <a:p/>
+              <a:t>Humane conduct joins values, character and ethics. The thirty-value canon has four jeevan values, six human values, nine established relationship values, nine expressed values and two object values. Happiness, peace, contentment and bliss principally concern realised fulfilment. Fortitude, courage, generosity, kindness, grace and compassion give humane direction to thought. Established values and their expressions belong principally to behaviour, while usefulness and aesthetic value concern work. These four dimensions involve the whole person. Generosity appears both as a human value and as care’s expression. Trust is common to relationships, and love is the complete relationship value. Character and ethics make these values effective through rightful participation and the right-use of body, mind and wealth. Genuine care can precede comprehensive awakening and become a basis for further understanding.</a:t>
+            </a:r>
+          </a:p>
+          <a:p>
+            <a:r>
+              <a:t/>
+            </a:r>
+          </a:p>
           <a:p>
             <a:r>
               <a:t>[Sources]</a:t>
@@ -1574,12 +1626,12 @@
           </a:p>
           <a:p>
             <a:r>
-              <a:t>- Study §§7.8, 10.3</a:t>
-            </a:r>
-          </a:p>
-          <a:p>
-            <a:r>
-              <a:t>- JV pp. 54–55; MVD p. 305; KD pp. 63, 67</a:t>
+              <a:t>- Study §§7.8–7.9,10.3; Axiology §§1.1–1.8</a:t>
+            </a:r>
+          </a:p>
+          <a:p>
+            <a:r>
+              <a:t>- PS printed pp.149,151,154; MAD reader pp.30,34; MVD pp.60–61,305–306; MSM printed p.49; KD pp.63,67</a:t>
             </a:r>
           </a:p>
         </p:txBody>
@@ -1649,10 +1701,14 @@
           <a:lstStyle/>
           <a:p>
             <a:r>
-              <a:t>Human action is karma: activity together with aspiration — never bare motion. Its result is broader than a changed configuration: something changes inside, in the body, in the relationship, and in nature. A later activity of the same jeevan can take that consequence as its object — that is evaluation, and it is what links one act to the next. The study distils three recurring shapes. Deluded evaluation: the relationship is recognised, but the pleasant, healthy, or profitable decides, and the value goes unfulfilled. Missing recognition: sincere intention with no recognised relationship — here more effort does not help; study does. Fulfilled practice: recognition, karma with aspiration, tasted value, mutual satisfaction — sustained across contexts.</a:t>
-            </a:r>
-          </a:p>
-          <a:p/>
+              <a:t>A shared garden connects care, guidance and useful work. A caregiver can meet a learner’s need while fuller understanding is developing. A learner can copy a watering task before understanding how soil and weather change the need. Teaching should examine what was understood and what remains to be learned. A sound plan may also lack water, tools or bodily assistance, which calls for practical provision. An abundant harvest can coexist with soil damage or excluded participants. Evaluation therefore examines the actual responsibility, contribution and consequences, including delayed effects and each affected standpoint. The participants can correct the method, provide assistance and develop independent capability. A particular fulfilled act supplies evidence of that contribution. Wider continuity requires further evidence through changing responsibilities and successors.</a:t>
+            </a:r>
+          </a:p>
+          <a:p>
+            <a:r>
+              <a:t/>
+            </a:r>
+          </a:p>
           <a:p>
             <a:r>
               <a:t>[Sources]</a:t>
@@ -1660,12 +1716,12 @@
           </a:p>
           <a:p>
             <a:r>
-              <a:t>- Study §§8.1–8.5</a:t>
-            </a:r>
-          </a:p>
-          <a:p>
-            <a:r>
-              <a:t>- KD pp. 1–3, 63, 65</a:t>
+              <a:t>- Study §§8.2–8.5,11.1–11.6</a:t>
+            </a:r>
+          </a:p>
+          <a:p>
+            <a:r>
+              <a:t>- KD pp.1–3,63,65; MSM printed p.49; MVD pp.311,336</a:t>
             </a:r>
           </a:p>
         </p:txBody>
@@ -1735,10 +1791,14 @@
           <a:lstStyle/>
           <a:p>
             <a:r>
-              <a:t>Movement Four puts the pieces back together. The four orders are one process, not four mechanisms — and the human addition is answerability, not a new engine. We will read the sixfold grammar — niyam, niyantran, santulan, nyaya, dharma, satya — as two coupled triads; place the four jeevan values as nested harmonies; define the two completenesses; and end where the darshan ends: evidence in relationship, work, and society.</a:t>
-            </a:r>
-          </a:p>
-          <a:p/>
+              <a:t>The same process now reaches human fulfilment and its social continuation. The sixfold account connects lawfulness, regulation and balance with justice, dharma and truth. The four jeevan values describe internal harmonies, and their fulfilment in living is cumulative through resolution, prosperity, fearlessness and coexistence. Param anand is the highest realised fulfilment and its continuity. Five social functions, humane constitution and wider coordination sustain the opportunities through which further people can understand and participate.</a:t>
+            </a:r>
+          </a:p>
+          <a:p>
+            <a:r>
+              <a:t/>
+            </a:r>
+          </a:p>
           <a:p>
             <a:r>
               <a:t>[Sources]</a:t>
@@ -1751,7 +1811,7 @@
           </a:p>
           <a:p>
             <a:r>
-              <a:t>- MVD pp. 32, 174; SB pp. 231–236; JV pp. 60–61, 97–98, 137–139</a:t>
+              <a:t>- MVD pp.174,315,327; KD printed p.112; JV printed pp.109–110,140</a:t>
             </a:r>
           </a:p>
         </p:txBody>
@@ -1821,10 +1881,14 @@
           <a:lstStyle/>
           <a:p>
             <a:r>
-              <a:t>Seen whole, the model is one process in three layers. The ground is standing: saturation, order-relative responsiveness, and niyati-kram never take turns — they are always in force. Within every occurrence, actual mutuality and conformance make a relation available; the unit expresses one complete effort–motion–result; fulfilment evidences complementarity; mediative activity regulates; and the result joins the next situation. In the human joint form, a third layer opens: realised knowledge can govern the same occurrence through the faculties, and consequence returns as evidence. Two things — and only two — are new at the human threshold: recognition can fail, and essential nature can be refined.</a:t>
-            </a:r>
-          </a:p>
-          <a:p/>
+              <a:t>Coexistence is the standing ground of continuously active units. In each occurrence, actual mutuality and conformance condition participation. Recognition and fulfilment evidence complementarity, and mediative activity sustains balance. Human imagination and freedom make chosen purposes, inquiry and the correction of mistakes possible. Knowing and believing can guide recognition and fulfilment, while consequences become available for later evaluation. Awakening is the necessary fulfilment of this human possibility: understanding gives freedom a comprehensive humane direction. Education and maintained arrangements carry that fulfilment into an awakened tradition. The study’s open problems examine the relation between this developmental direction and particular historical paths.</a:t>
+            </a:r>
+          </a:p>
+          <a:p>
+            <a:r>
+              <a:t/>
+            </a:r>
+          </a:p>
           <a:p>
             <a:r>
               <a:t>[Sources]</a:t>
@@ -1832,12 +1896,12 @@
           </a:p>
           <a:p>
             <a:r>
-              <a:t>- Study §§9.1–9.2</a:t>
-            </a:r>
-          </a:p>
-          <a:p>
-            <a:r>
-              <a:t>- SB pp. 231–236; MVD pp. 48, 154</a:t>
+              <a:t>- Study §§9.1–9.4,12</a:t>
+            </a:r>
+          </a:p>
+          <a:p>
+            <a:r>
+              <a:t>- SB pp.19–20,231–240,248–249,283–284; MVD pp.104,230</a:t>
             </a:r>
           </a:p>
         </p:txBody>
@@ -1907,10 +1971,14 @@
           <a:lstStyle/>
           <a:p>
             <a:r>
-              <a:t>Six terms govern the whole account, and they come as two triads. Niyam, niyantran, santulan — lawfulness, regulation, balance — are manifest in nature: material activity distinctly shows law, pranic shows regulation, animal shows balance. Nyaya, dharma, satya — justice, dharma, truth — are human activities: justice regulates behaviour, dharma disciplines thought, and realisation takes place only through truth. The second triad is how humans understand and establish the first in work and arrangements. The pairings on the chips are diagnostic questions — does conduct follow the law of the relationship? does thought keep operation regulated? does the complete picture stay balanced in truth? — not assignments of ownership.</a:t>
-            </a:r>
-          </a:p>
-          <a:p/>
+              <a:t>Lawfulness, regulation and balance are evident throughout natural participation. Human beings understand them and take responsibility for their own work and arrangements. Justice concerns recognised and fulfilled relationships, correctly evaluated to mutual satisfaction. Human dharma is happiness fulfilled through resolution and participation in orderliness. Truth is coexistence realised as the complete reality. The pairings help examine whether conduct fulfils the relationship, regulation sustains its purpose, and the complete arrangement remains balanced. The whole faculty organisation participates in these questions, with justice, dharma and truth governing deliberation together.</a:t>
+            </a:r>
+          </a:p>
+          <a:p>
+            <a:r>
+              <a:t/>
+            </a:r>
+          </a:p>
           <a:p>
             <a:r>
               <a:t>[Sources]</a:t>
@@ -1918,12 +1986,12 @@
           </a:p>
           <a:p>
             <a:r>
-              <a:t>- Study §§7.4, 8.3, 11.2</a:t>
-            </a:r>
-          </a:p>
-          <a:p>
-            <a:r>
-              <a:t>- MVD pp. 32, 137, 174; SB pp. 231–236</a:t>
+              <a:t>- Study §§7.4,8.3,11.2</a:t>
+            </a:r>
+          </a:p>
+          <a:p>
+            <a:r>
+              <a:t>- MVD pp.32,137,174,311,336; SB pp.231–236</a:t>
             </a:r>
           </a:p>
         </p:txBody>
@@ -1993,10 +2061,14 @@
           <a:lstStyle/>
           <a:p>
             <a:r>
-              <a:t>Where does the sought happiness actually live? The four jeevan values are harmonies between adjacent faculties. Happiness is harmony of mun with vritti — the texts define it simply as resolution. Peace is harmony of vritti with chitta; contentment of chitta with buddhi; bliss of buddhi with atma; and paramanand — ultimate bliss — is realisation in coexistence at atma. The ladder is nested, not cumulative: each harmony is borne in the outer faculty of its pair, conditioned on concurrence with the inner one. That is why sustained dissatisfaction is real evidence about the whole ladder — and why no object, purchase, or achievement can supply what only concurrence within jeevan establishes.</a:t>
-            </a:r>
-          </a:p>
-          <a:p/>
+              <a:t>The four jeevan values name concordance between adjacent faculties in their truthful and humane content. Happiness joins mun and vritti in resolution and conduct free of wrongdoing. Peace joins vritti and chitta in thought free of injustice. Contentment joins chitta and buddhi in desire free of attachment. Bliss joins buddhi and atma in understanding free of ignorance. Their fulfilment in living is cumulative: resolution brings happiness; resolution with prosperity brings peace; their fulfilment with fearlessness brings contentment; all these with coexistence bring bliss. These broader goals require actual means and participation at the relevant scope. Param anand is the highest human goal, the realisation of coexistence in continuity, expressed through resolved thought, just behaviour and purposeful work.</a:t>
+            </a:r>
+          </a:p>
+          <a:p>
+            <a:r>
+              <a:t/>
+            </a:r>
+          </a:p>
           <a:p>
             <a:r>
               <a:t>[Sources]</a:t>
@@ -2004,12 +2076,12 @@
           </a:p>
           <a:p>
             <a:r>
-              <a:t>- Study §§10.1, 8.4</a:t>
-            </a:r>
-          </a:p>
-          <a:p>
-            <a:r>
-              <a:t>- MVD pp. 100–101; JV pp. 137–138</a:t>
+              <a:t>- Study §10.1</a:t>
+            </a:r>
+          </a:p>
+          <a:p>
+            <a:r>
+              <a:t>- MVD pp.101,327–328; MAD reader pp.47,51; KD printed p.112; AVD p.262</a:t>
             </a:r>
           </a:p>
         </p:txBody>
@@ -2079,10 +2151,14 @@
           <a:lstStyle/>
           <a:p>
             <a:r>
-              <a:t>The destination has two names. Activity completeness — kriyapurnata — is the restfulness of effort: coexistence realised as truth in atma, the three contents of knowledge enlightened in buddhi, all ten activities effective, and the full nested harmony sustained. Understand restfulness carefully: it is resolution, not stillness — jeevan continues in effort, motion, and result like every unit; what has ceased is the unresolved striving that dissatisfaction sustained. Conduct completeness — acharanpurnata — is that same attainment made public: stable humane conduct, in values, character, and ethics, across the diversity of one’s relationships and work. Neither is certified by a single good act; practice across contexts is the test.</a:t>
-            </a:r>
-          </a:p>
-          <a:p/>
+              <a:t>Activity completeness is restfulness in realised activity. Coexistence is realised in atma, complete knowledge is enlightened in buddhi, and the ten activities operate in practised harmony. Conduct completeness gives that fulfilment continuing expression through values, character and ethics across changing situations. Purposeful activity continues as the person contributes and helps others understand. Three scopes of continuity are connected: realisation in jeevan, sustained humane conduct through the person’s life, and awakened tradition across persons and generations. Each scope requires its own evidence of the understanding and participation involved.</a:t>
+            </a:r>
+          </a:p>
+          <a:p>
+            <a:r>
+              <a:t/>
+            </a:r>
+          </a:p>
           <a:p>
             <a:r>
               <a:t>[Sources]</a:t>
@@ -2090,12 +2166,12 @@
           </a:p>
           <a:p>
             <a:r>
-              <a:t>- Study §§10.2–10.3</a:t>
-            </a:r>
-          </a:p>
-          <a:p>
-            <a:r>
-              <a:t>- MVD pp. 102–104; SB p. 58; KD p. 65</a:t>
+              <a:t>- Study §§10.2–10.3 and Appendix C</a:t>
+            </a:r>
+          </a:p>
+          <a:p>
+            <a:r>
+              <a:t>- MVD pp.68,94,102–104,315,327; AVD pp.114,262; SB p.58; KD p.65</a:t>
             </a:r>
           </a:p>
         </p:txBody>
@@ -2165,10 +2241,14 @@
           <a:lstStyle/>
           <a:p>
             <a:r>
-              <a:t>How is orderliness verified in an actual arrangement — a family practice, a work process, an organisation? The study turns the sixfold grammar into six questions, each with its own evidence. Is the law of the activity — its rightful purpose and limits — correctly identified? Is operation actually regulated toward it, with feedback and correction? Are persons, functions, and nature mutually sustaining? Are relationships recognised and fulfilled to mutual satisfaction? Do purpose and participation sustain resolution? Does the complete account stand in truth? The six are not averaged: a just relationship can coexist with ecological imbalance, and a well-regulated process can pursue a wrong law. And no arrangement is a jeevan — only its participants understand and evaluate.</a:t>
-            </a:r>
-          </a:p>
-          <a:p/>
+              <a:t>The sixfold questions make evaluation concrete. Participants identify the activity, its rightful purpose and its requirements. They examine whether operation remains regulated through capability, feedback and correction. They assess the effects upon persons and natural conditions. Justice requires recognised relationship, actual value fulfilment, correct evaluation and mutual satisfaction. Dharma concerns resolution and participation in overall orderliness, while truth concerns the complete understanding of coexistence and its expression. A disputed assessment calls for further evidence and dialogue. In the garden, the learner’s understanding, the caregiver’s contribution, the food recipients’ needs and the soil’s condition each matter to the whole undertaking.</a:t>
+            </a:r>
+          </a:p>
+          <a:p>
+            <a:r>
+              <a:t/>
+            </a:r>
+          </a:p>
           <a:p>
             <a:r>
               <a:t>[Sources]</a:t>
@@ -2176,12 +2256,12 @@
           </a:p>
           <a:p>
             <a:r>
-              <a:t>- Study §§8.3, 11.2</a:t>
-            </a:r>
-          </a:p>
-          <a:p>
-            <a:r>
-              <a:t>- MVD pp. 287–288; JV pp. 97–98, 137–139</a:t>
+              <a:t>- Study §§8.3,11.1–11.2</a:t>
+            </a:r>
+          </a:p>
+          <a:p>
+            <a:r>
+              <a:t>- MVD pp.287–288,311,336; JV printed pp.97–98,137–139</a:t>
             </a:r>
           </a:p>
         </p:txBody>
@@ -2251,10 +2331,14 @@
           <a:lstStyle/>
           <a:p>
             <a:r>
-              <a:t>The human goals form one linked sequence: resolved individual, prosperous family, fearless society, universal coexistence. Resolution is lived as happiness; prosperity supports peace in the family; fearlessness supports contentment in society; and understanding is evidenced as bliss in participation. These four are the public face of the same order whose inner face is the nested jeevan values. The study is careful here: the chain is a stated direction of evidence, not a theorem — it does not pretend to derive society from individual traces. Each scale has to be maintained the way every relational order is maintained: recognition, value-fulfilment, regulated work, evaluation.</a:t>
-            </a:r>
-          </a:p>
-          <a:p/>
+              <a:t>The human goals connect resolution in the individual, prosperity in the family, fearlessness in society and coexistence in universal participation. Five functions sustain their practical fulfilment. Education–sanskar makes understanding and humane capability available. Justice–security maintains responsibilities and corrects injustice. Health–restraint supports bodily capability and disciplined use. Production–work provides useful things with nature. Exchange–storage maintains availability across persons and times. In the garden these functions meet through teaching, suitable tasks, cultivation, food distribution, seed storage and joint evaluation. Each depends on the others. Children, elders and people needing assistance belong within the provision and the opportunity to participate.</a:t>
+            </a:r>
+          </a:p>
+          <a:p>
+            <a:r>
+              <a:t/>
+            </a:r>
+          </a:p>
           <a:p>
             <a:r>
               <a:t>[Sources]</a:t>
@@ -2262,12 +2346,12 @@
           </a:p>
           <a:p>
             <a:r>
-              <a:t>- Study §§11.3, 12.7</a:t>
-            </a:r>
-          </a:p>
-          <a:p>
-            <a:r>
-              <a:t>- JV pp. 60–61; SB pp. 246–247</a:t>
+              <a:t>- Study §§11.3–11.4</a:t>
+            </a:r>
+          </a:p>
+          <a:p>
+            <a:r>
+              <a:t>- JV printed pp.60–61,109–110,140; MSM printed pp.64–65; KD printed p.112; MVD pp.56–57</a:t>
             </a:r>
           </a:p>
         </p:txBody>
@@ -2337,10 +2421,14 @@
           <a:lstStyle/>
           <a:p>
             <a:r>
-              <a:t>A source-faithful reconstruction also says what it cannot show. Four limits matter most. There is no accepted physical identification of constitutional completeness — no instrument picks out the jeevan atom. The body–jeevan interface is stated functionally, not mechanistically. The whole account is qualitative: no common numerical scale spans strength, harmony, and value. And the social chain — individual to family to society — is a direction of evidence, not a derived theorem. Treat these as standing questions the tradition can work on honestly. Claiming more than the texts and evidence carry does not strengthen the darshan; it weakens the trust its evidence-first stance earns.</a:t>
-            </a:r>
-          </a:p>
-          <a:p/>
+              <a:t>Family-based self-governance extends responsibility toward the world family. Within the first tier, the family council deliberates and the family carries the decisions into living. Wider coordination proceeds through family clusters, village-family councils, village or neighbourhood clusters, kshetra, mandal, mandal clusters, mukhya rajya, pradhan rajya and the world-family council. The proposal emphasises dialogue, representation and consensus. These arrangements need understood purposes, capable contributions, suitable means and continuing evaluation. Humane constitution, samvidhan, articulates values, character, ethics and responsibilities across family, society, vocation and nature. Its social meaning is distinct from jeevan’s atomic constitution, gathan. The study retains questions about how particular arrangements and consensus procedures function under difficult conditions.</a:t>
+            </a:r>
+          </a:p>
+          <a:p>
+            <a:r>
+              <a:t/>
+            </a:r>
+          </a:p>
           <a:p>
             <a:r>
               <a:t>[Sources]</a:t>
@@ -2348,12 +2436,12 @@
           </a:p>
           <a:p>
             <a:r>
-              <a:t>- Study §12 (open problems)</a:t>
-            </a:r>
-          </a:p>
-          <a:p>
-            <a:r>
-              <a:t>- Study Appendix C (proposed criteria, kept separate)</a:t>
+              <a:t>- Study §§11.5–11.6,12</a:t>
+            </a:r>
+          </a:p>
+          <a:p>
+            <a:r>
+              <a:t>- MVD pp.18–19,161,253; JVD PDF pp.237–238,249–328; JV printed p.126</a:t>
             </a:r>
           </a:p>
         </p:txBody>
@@ -2423,10 +2511,14 @@
           <a:lstStyle/>
           <a:p>
             <a:r>
-              <a:t>Movement One lays the ground. Before we can talk about cells, animals, or human conduct, the darshan settles two things: what exists, and why it is active. The answer is coexistence — satta and units, never apart — and saturation, which makes every unit energised without anything pushing it. We will also meet the claim that a unit simply is its activity: effort, motion, and result together, readable as form, property, essential nature, and dharma.</a:t>
-            </a:r>
-          </a:p>
-          <a:p/>
+              <a:t>Coexistence is the presence of pervasive satta and bounded, active units. Saturation means that each unit is energised in that ground and participates through its own strength and power. A unit persists as the bearer of activity. Effort, motion and result describe its inseparable activity, while form, property, essential nature and dharma describe what the unit is and how it participates. This relation prepares the account of atoms, structural wholes, jeevan and humane conduct.</a:t>
+            </a:r>
+          </a:p>
+          <a:p>
+            <a:r>
+              <a:t/>
+            </a:r>
+          </a:p>
           <a:p>
             <a:r>
               <a:t>[Sources]</a:t>
@@ -2439,7 +2531,7 @@
           </a:p>
           <a:p>
             <a:r>
-              <a:t>- MVD pp. 26, 34–48; SB pp. 48–62</a:t>
+              <a:t>- MVD pp.34–48; SB pp.58–62,256–257</a:t>
             </a:r>
           </a:p>
         </p:txBody>
@@ -2509,10 +2601,14 @@
           <a:lstStyle/>
           <a:p>
             <a:r>
-              <a:t>The whole in six steps. Actionless, state-complete satta coexists with saturated units. Every unit is one effort–motion–result, readable as form, property, essential nature, and dharma. In actual mutuality, recognition and fulfilment evidence complementarity, and mediative activity keeps balance — natural orderliness. Closures build molecules, cells, and bodies, while one atomic line yields jeevan, and their meeting manifests animal and human orders. At the human threshold, recognition and fulfilment become consciously answerable — and therefore failable. And realised knowledge, projected through the faculties, makes truth, dharma, and justice effective in thought, relationship, work, and maintained arrangements. Read the study for the full argument, the citations, and the open problems — at AnalyticMadhyasthDarshan.org.</a:t>
-            </a:r>
-          </a:p>
-          <a:p/>
+              <a:t>The argument culminates in continuous awakened living. Realisation of coexistence fulfils jeevan as paramanand, and that understanding becomes evident through humane thought, behaviour and work. Education, humane constitution and maintained systems preserve opportunities for further people to understand and participate. In the garden, learners come to explain the purpose, take responsibility, provide for others, sustain the soil and evaluate their decisions. The next participants can then continue and refine the undertaking. This joins continuity within jeevan, continuity of humane conduct and continuity of awakened tradition across generations. Undivided society and universal orderliness name the comprehensive social fulfilment of that participation.</a:t>
+            </a:r>
+          </a:p>
+          <a:p>
+            <a:r>
+              <a:t/>
+            </a:r>
+          </a:p>
           <a:p>
             <a:r>
               <a:t>[Sources]</a:t>
@@ -2520,12 +2616,12 @@
           </a:p>
           <a:p>
             <a:r>
-              <a:t>- A State-Dynamic Model of Coexistence — Conclusion</a:t>
-            </a:r>
-          </a:p>
-          <a:p>
-            <a:r>
-              <a:t>- MVD; SB; JV; KD — pages as cited on each slide</a:t>
+              <a:t>- Study §§10–11 and Conclusion</a:t>
+            </a:r>
+          </a:p>
+          <a:p>
+            <a:r>
+              <a:t>- MVD pp.94,315,321,327,338–339; SB pp.19–20,234–240; AVD pp.114,262; KD printed p.112</a:t>
             </a:r>
           </a:p>
         </p:txBody>
@@ -2595,10 +2691,14 @@
           <a:lstStyle/>
           <a:p>
             <a:r>
-              <a:t>Existence is neither a heap of dead matter nor a formless field. It is coexistence: satta — unbounded, uniform, actionless Omnipresence — and countless discrete units present in it. The units are state-dynamic: state and motion are never separated in them. Saturation is the key word: each unit is soaked, submerged, and surrounded in satta, and that is why it is energised and forceful. Notice what is denied: satta never pushes, never transfers energy from a store, and no unit can be drained of what it is never separated from. The perpetual activity of atoms is the standing evidence.</a:t>
-            </a:r>
-          </a:p>
-          <a:p/>
+              <a:t>Existence is coexistence. Satta is unbounded, uniform and actionless. Countless bounded units remain present in it, each inseparably in state and motion. Saturation expresses how every unit is soaked, submerged and surrounded in this pervasive ground. The unit is therefore energised and forceful through its own activity. Satta remains complete throughout the development and awakening of units. As Knowledge, that same ground is available to realisation through jeevan.</a:t>
+            </a:r>
+          </a:p>
+          <a:p>
+            <a:r>
+              <a:t/>
+            </a:r>
+          </a:p>
           <a:p>
             <a:r>
               <a:t>[Sources]</a:t>
@@ -2606,12 +2706,12 @@
           </a:p>
           <a:p>
             <a:r>
-              <a:t>- Study §§1–1.1</a:t>
-            </a:r>
-          </a:p>
-          <a:p>
-            <a:r>
-              <a:t>- MVD pp. 26, 34–46; SB pp. 48–57; JV p. 149</a:t>
+              <a:t>- Study §§1–1.1 and7.1</a:t>
+            </a:r>
+          </a:p>
+          <a:p>
+            <a:r>
+              <a:t>- MVD pp.26,34–46,97–100; SB pp.48–57</a:t>
             </a:r>
           </a:p>
         </p:txBody>
@@ -2681,10 +2781,14 @@
           <a:lstStyle/>
           <a:p>
             <a:r>
-              <a:t>Here is the study’s central re-orientation. We usually imagine a thing that then acts. The texts say instead: every physical-chemical activity is an inseparable presence of effort, motion, and result. Effort is strength borne in state; motion is power operating; result is the realised form. There is no inert carrier underneath waiting to be moved. So the study speaks of a unit as a ‘closed activity’ — an activity that holds a boundary and persists. And there are no pauses: the result of one complete occurrence is already the force-bearing state facing the next.</a:t>
-            </a:r>
-          </a:p>
-          <a:p/>
+              <a:t>An atom, molecule, cell or body persists through its activity. The active bearer is guni, and its relative power in mutuality is guna. Effort is strength in state, motion is power in operation, and result is the form realised through that activity. These aspects occur together. The unit remains available for further participation, and each realised result contributes to the conditions it faces. This connects persistent units with changing activities and consequences.</a:t>
+            </a:r>
+          </a:p>
+          <a:p>
+            <a:r>
+              <a:t/>
+            </a:r>
+          </a:p>
           <a:p>
             <a:r>
               <a:t>[Sources]</a:t>
@@ -2692,12 +2796,12 @@
           </a:p>
           <a:p>
             <a:r>
-              <a:t>- Study §§1.2, 1.4, 2</a:t>
-            </a:r>
-          </a:p>
-          <a:p>
-            <a:r>
-              <a:t>- SB pp. 58–62; KD §3.8 p. 84, §3.11 pp. 102–109</a:t>
+              <a:t>- Study §§1.2–1.4,2</a:t>
+            </a:r>
+          </a:p>
+          <a:p>
+            <a:r>
+              <a:t>- SB pp.58–62,256–257; KD §3.8 p.84, §3.11 pp.102–109</a:t>
             </a:r>
           </a:p>
         </p:txBody>
@@ -2767,10 +2871,14 @@
           <a:lstStyle/>
           <a:p>
             <a:r>
-              <a:t>The four aspects — form, property, essential nature, and dharma — are familiar to every student of the darshan. The study’s point is that they are not four possessions of an underlying thing: they are the same single activity read aspectually. And the two readings align: effort or strength is present as dharma with svabhav; motion or power as svabhav with guna; result as roop. Dharma deserves special care. It is innateness — existence for material units, growth added for pranic, hope to live for animal, happiness for human. It is a criterion of fulfilment, not a force that pushes, and not information stored inside the unit.</a:t>
-            </a:r>
-          </a:p>
-          <a:p/>
+              <a:t>Form identifies the unit and its configuration. Property concerns the relative power effective in a particular mutuality, including generative, degenerative and mediative effects. Essential nature concerns characteristic conduct and its functional significance. Dharma is innateness and the criterion of fulfilment. These aspects belong to the active unit together. The effort–motion–result account connects dharma and essential nature in state, essential nature and property in motion, and form with result. A genuine whole and its constituents each require their appropriate description.</a:t>
+            </a:r>
+          </a:p>
+          <a:p>
+            <a:r>
+              <a:t/>
+            </a:r>
+          </a:p>
           <a:p>
             <a:r>
               <a:t>[Sources]</a:t>
@@ -2778,12 +2886,12 @@
           </a:p>
           <a:p>
             <a:r>
-              <a:t>- Study §§1.3, 3.1–3.4</a:t>
-            </a:r>
-          </a:p>
-          <a:p>
-            <a:r>
-              <a:t>- MVD p. 47; SB pp. 60–62; KD §§3.9–3.10 pp. 98–102</a:t>
+              <a:t>- Study §§1.3,3.1–3.4,5.4</a:t>
+            </a:r>
+          </a:p>
+          <a:p>
+            <a:r>
+              <a:t>- MVD pp.47,50–51; SB pp.60–62,256–257</a:t>
             </a:r>
           </a:p>
         </p:txBody>
@@ -2853,10 +2961,14 @@
           <a:lstStyle/>
           <a:p>
             <a:r>
-              <a:t>No unit is met in isolation. In every order, units recognise and fulfil according to what they are — an atomic particle recognises other particles and holds a definite distance; this is definite responsiveness, not conscious perception. Complementarity shows itself in offering, acceptance, nourishment, and fulfilment. Among the three tendencies of property, the mediative one regulates the generative and degenerative and maintains balance. This is where lawfulness, regulation, and balance — niyam, niyantran, santulan — are grounded: not decreed by an acting God, but evident in how saturated units meet. And because every result becomes part of the next situation, the whole is a running system, not a list.</a:t>
-            </a:r>
-          </a:p>
-          <a:p/>
+              <a:t>Units participate in actual mutuality. Natural recognition and fulfilment have the definite form appropriate to the unit and its order. Complementarity becomes evident through offering, acceptance and fulfilled participation. Mediative activity regulates generative and degenerative tendencies and sustains balance. Lawfulness, regulation and balance therefore have a natural manifestation. Humans can understand these relationships, evaluate their own contribution and establish conscious participation within them.</a:t>
+            </a:r>
+          </a:p>
+          <a:p>
+            <a:r>
+              <a:t/>
+            </a:r>
+          </a:p>
           <a:p>
             <a:r>
               <a:t>[Sources]</a:t>
@@ -2864,12 +2976,12 @@
           </a:p>
           <a:p>
             <a:r>
-              <a:t>- Study §§1.5, 2.3</a:t>
-            </a:r>
-          </a:p>
-          <a:p>
-            <a:r>
-              <a:t>- JV pp. 69–70; SB pp. 99, 143–144, 249–251; MVD pp. 25–26, 48, 154</a:t>
+              <a:t>- Study §§1.5,2.3,9.2</a:t>
+            </a:r>
+          </a:p>
+          <a:p>
+            <a:r>
+              <a:t>- JV printed pp.69–70; SB pp.143–144,249–251; MVD pp.48,154</a:t>
             </a:r>
           </a:p>
         </p:txBody>
@@ -2939,10 +3051,14 @@
           <a:lstStyle/>
           <a:p>
             <a:r>
-              <a:t>Movement Two builds the world we see. Two different processes must not be confused. Closure is how many activities come to run as one — molecules, compounds, cells, bodies. Development is what happens inside one atom on a different line, ending in constitutional completeness — jeevan. The four orders — material, pranic, animal, knowledge — organise both. Keeping the two lines separate is what prevents the mistake of treating the human as a later animal, or jeevan as a product of the body.</a:t>
-            </a:r>
-          </a:p>
-          <a:p/>
+              <a:t>Material composition and atomic development have related but distinct outcomes. Through composition, constituent units form wholes with bounded conduct, including molecules, cells and bodies. Atomic development reaches constitutional completeness in jeevan. The first process supplies bodily configurations, and the second establishes the enduring sentient unit. Their association makes animal and human manifestation possible. The four orders locate the characteristic activity and fulfilment present in each case.</a:t>
+            </a:r>
+          </a:p>
+          <a:p>
+            <a:r>
+              <a:t/>
+            </a:r>
+          </a:p>
           <a:p>
             <a:r>
               <a:t>[Sources]</a:t>
@@ -2955,7 +3071,7 @@
           </a:p>
           <a:p>
             <a:r>
-              <a:t>- KD §§3.1–3.3; MVD pp. 8, 13, 42, 91; SB pp. 55, 75–76</a:t>
+              <a:t>- MVD pp.8,13,42,91; SB pp.60–62,75–76</a:t>
             </a:r>
           </a:p>
         </p:txBody>
@@ -3025,10 +3141,14 @@
           <a:lstStyle/>
           <a:p>
             <a:r>
-              <a:t>The four orders in one view. Material units bear existence and show lawfulness through constitution- and result-conformance. Pranic units add growth and show regulation through seed-conformance. The animal order — an animal body joined with jeevan — adds the hope to live and shows balance through species-conformance. The knowledge order — the human — adds happiness, and here conformance is to sanskar: nothing fixes human conduct automatically, so law, regulation, and balance must be consciously understood and established. Note that animal and human bodies are themselves pranic; the animal and knowledge orders become manifest through association with jeevan.</a:t>
-            </a:r>
-          </a:p>
-          <a:p/>
+              <a:t>Material units bear existence and express lawfulness through constitution and results. Pranic units add growth, with regulation through seed-conformant activity. Animal manifestation joins a pranic body and jeevan, expressing species-conformant recognition and the hope to live. Human manifestation joins a developed bodily medium and jeevan, with the aspiration for happiness. Its conduct develops through understanding and sanskar. Humans already belong to knowledge order while that understanding is developing. Awakening establishes conscious participation in lawfulness, regulation and balance through justice, dharma and truth.</a:t>
+            </a:r>
+          </a:p>
+          <a:p>
+            <a:r>
+              <a:t/>
+            </a:r>
+          </a:p>
           <a:p>
             <a:r>
               <a:t>[Sources]</a:t>
@@ -3036,12 +3156,12 @@
           </a:p>
           <a:p>
             <a:r>
-              <a:t>- Study §§3.4–3.5</a:t>
-            </a:r>
-          </a:p>
-          <a:p>
-            <a:r>
-              <a:t>- MVD pp. 50, 115; SB pp. 179, 231–236; JV p. 47</a:t>
+              <a:t>- Study §§3.4–3.5,9.2–9.4</a:t>
+            </a:r>
+          </a:p>
+          <a:p>
+            <a:r>
+              <a:t>- MVD pp.26–27,47,50,115; SB pp.179,231–236; JV printed p.47</a:t>
             </a:r>
           </a:p>
         </p:txBody>
@@ -6551,7 +6671,7 @@
                 </a:solidFill>
                 <a:latin typeface="Calibri"/>
               </a:rPr>
-              <a:t>One process of coexistence — from the saturated atom to humane conduct and undivided society</a:t>
+              <a:t>Coexistence, the architecture of jeevan, and the continuity of awakened human living</a:t>
             </a:r>
           </a:p>
         </p:txBody>
@@ -6955,7 +7075,7 @@
                 </a:solidFill>
                 <a:latin typeface="Calibri"/>
               </a:rPr>
-              <a:t>No motion-path closes. Each component keeps exhibiting its own public conduct — sand and sugar stirred together.</a:t>
+              <a:t>Each component retains its own public conduct, as in sand and sugar stirred together.</a:t>
             </a:r>
           </a:p>
         </p:txBody>
@@ -7069,7 +7189,7 @@
                 </a:solidFill>
                 <a:latin typeface="Calibri"/>
               </a:rPr>
-              <a:t>Complementary activities close a new motion-path. The whole shows its own conduct and four aspects; the constituents continue within it.</a:t>
+              <a:t>Constituents participate in a bounded whole with its own conduct and four aspects. Their activities continue within it.</a:t>
             </a:r>
           </a:p>
         </p:txBody>
@@ -7148,7 +7268,7 @@
                 </a:solidFill>
                 <a:latin typeface="Calibri"/>
               </a:rPr>
-              <a:t>A closure is a new unit</a:t>
+              <a:t>A closure is a new unit:</a:t>
             </a:r>
             <a:r>
               <a:rPr sz="1300" b="0" i="0">
@@ -7157,7 +7277,7 @@
                 </a:solidFill>
                 <a:latin typeface="Calibri"/>
               </a:rPr>
-              <a:t>  —  molecule, compound, cell, body — each a new closed activity</a:t>
+              <a:t> a molecule, compound, cell or body with bounded conduct.</a:t>
             </a:r>
           </a:p>
         </p:txBody>
@@ -7236,7 +7356,7 @@
                 </a:solidFill>
                 <a:latin typeface="Calibri"/>
               </a:rPr>
-              <a:t>Constituents persist</a:t>
+              <a:t>Constituents persist.</a:t>
             </a:r>
             <a:r>
               <a:rPr sz="1300" b="0" i="0">
@@ -7245,7 +7365,7 @@
                 </a:solidFill>
                 <a:latin typeface="Calibri"/>
               </a:rPr>
-              <a:t>  —  they are never melted into homogeneous stuff</a:t>
+              <a:t> Their participation sustains the whole.</a:t>
             </a:r>
           </a:p>
         </p:txBody>
@@ -7324,7 +7444,7 @@
                 </a:solidFill>
                 <a:latin typeface="Calibri"/>
               </a:rPr>
-              <a:t>Disintegration removes only the closure</a:t>
+              <a:t>Disintegration changes the whole’s organisation.</a:t>
             </a:r>
             <a:r>
               <a:rPr sz="1300" b="0" i="0">
@@ -7333,7 +7453,7 @@
                 </a:solidFill>
                 <a:latin typeface="Calibri"/>
               </a:rPr>
-              <a:t>  —  nothing is annihilated — there was no extra substance</a:t>
+              <a:t> Constituent units continue their activity.</a:t>
             </a:r>
           </a:p>
         </p:txBody>
@@ -7588,7 +7708,7 @@
                 </a:solidFill>
                 <a:latin typeface="Cambria"/>
               </a:rPr>
-              <a:t>Two Lines of Development</a:t>
+              <a:t>Composition and Atomic Development</a:t>
             </a:r>
           </a:p>
         </p:txBody>
@@ -7702,8 +7822,8 @@
                 </a:solidFill>
                 <a:latin typeface="Calibri"/>
               </a:rPr>
-              <a:t>Atom → molecule → compound and mineral → pranic cell → plant, animal, and human bodies.
-Each step is a new containing activity. A body remains of the order of what composes it — a plant body is pranic, not jeevan.</a:t>
+              <a:t>Atoms participate in molecules, compounds and minerals. Pranic activity sustains cells and the development of bodies.
+A structural whole has its own conduct, with constituents continuing within it.</a:t>
             </a:r>
           </a:p>
         </p:txBody>
@@ -7817,8 +7937,8 @@
                 </a:solidFill>
                 <a:latin typeface="Calibri"/>
               </a:rPr>
-              <a:t>A developing atom completes its own particle constitution (gathanpurnata).
-Nothing joins anything: the same unit changes kind, irreversibly, and is then jeevan — the sentient unit.</a:t>
+              <a:t>Atomic development reaches constitutional completeness, gathanpurnata.
+The constitutionally complete atom is jeevan, an enduring sentient unit with inexhaustible strength and power.</a:t>
             </a:r>
           </a:p>
         </p:txBody>
@@ -7897,7 +8017,7 @@
                 </a:solidFill>
                 <a:latin typeface="Calibri"/>
               </a:rPr>
-              <a:t>The lines meet in animal and human joint forms. The human is not the next animal — the two joint forms stand side by side, not on one ladder.</a:t>
+              <a:t>Compatible bodies and jeevan associate in animal and human manifestation. Each has the activity and fulfilment appropriate to its order.</a:t>
             </a:r>
           </a:p>
         </p:txBody>
@@ -8987,7 +9107,7 @@
                 </a:solidFill>
                 <a:latin typeface="Calibri"/>
               </a:rPr>
-              <a:t>Jeevan expresses the hope to live through a species-conformant body: recognition of friendliness and opposition, tasting, selection — without the knowing-and-believing circuit.</a:t>
+              <a:t>The enduring jeevan expresses species-conformant recognition, tasting and selection through the animal body, with the hope to live.</a:t>
             </a:r>
           </a:p>
         </p:txBody>
@@ -9101,7 +9221,7 @@
                 </a:solidFill>
                 <a:latin typeface="Calibri"/>
               </a:rPr>
-              <a:t>A developed bodily medium through which cognisance can govern sensitivity. Recognition can now fail — and can be studied, corrected, and refined.</a:t>
+              <a:t>Imagination and freedom allow inquiry, chosen conduct and correction. Cognisance can govern sensitivity through understanding.</a:t>
             </a:r>
           </a:p>
         </p:txBody>
@@ -9180,7 +9300,7 @@
                 </a:solidFill>
                 <a:latin typeface="Calibri"/>
               </a:rPr>
-              <a:t>Association, not fusion: the body remains pranic, jeevan remains jeevan. Delusion does not dissolve the association — realised values are not what hold body and jeevan together.</a:t>
+              <a:t>The body remains pranic and jeevan retains its complete faculty organisation. Their association provides the medium for embodied participation.</a:t>
             </a:r>
           </a:p>
         </p:txBody>
@@ -9584,7 +9704,7 @@
                 </a:solidFill>
                 <a:latin typeface="Calibri"/>
               </a:rPr>
-              <a:t>Molecule, compound, cell, body: a configuration holds by itself. No recognition is asked of anyone.</a:t>
+              <a:t>Molecule, compound, cell or body: constituents sustain a bounded whole through their definite participation.</a:t>
             </a:r>
           </a:p>
         </p:txBody>
@@ -9891,7 +10011,7 @@
                 </a:solidFill>
                 <a:latin typeface="Calibri"/>
               </a:rPr>
-              <a:t>A family is not a compound, and an organisation has no jeevan of its own. Misrecognition does not erase a relationship — it damages its just fulfilment.</a:t>
+              <a:t>Actual relationships remain present through misunderstanding. Understanding and fulfilled responsibilities sustain their humane expression.</a:t>
             </a:r>
           </a:p>
         </p:txBody>
@@ -10453,7 +10573,7 @@
                 </a:solidFill>
                 <a:latin typeface="Calibri"/>
               </a:rPr>
-              <a:t>The same jeevan can live from four and a half activities in delusion, or from all ten in awakening.</a:t>
+              <a:t>Jeevan’s ten activities remain present. Awakening makes their comprehensive understanding and humane expression effective.</a:t>
             </a:r>
           </a:p>
         </p:txBody>
@@ -10743,7 +10863,7 @@
                 </a:solidFill>
                 <a:latin typeface="Cambria"/>
               </a:rPr>
-              <a:t>Five Faculties, Ten Activities</a:t>
+              <a:t>Jeevan’s Concentric Architecture</a:t>
             </a:r>
           </a:p>
         </p:txBody>
@@ -10778,7 +10898,7 @@
                 </a:solidFill>
                 <a:latin typeface="Calibri"/>
               </a:rPr>
-              <a:t>Each faculty bears one activity in state (bal — strength) and one in motion (shakti — power): the same pairing every unit shows.</a:t>
+              <a:t>Atma is central. Buddhi, chitta, vritti and mun occupy four successive orbits. Each faculty has one generic activity pair.</a:t>
             </a:r>
           </a:p>
         </p:txBody>
@@ -12068,7 +12188,7 @@
                 </a:solidFill>
                 <a:latin typeface="Calibri"/>
               </a:rPr>
-              <a:t>In finer grain the texts name 61 bal–shakti positions — 122 activities — as the vocabulary these ten work over.</a:t>
+              <a:t>61 detailed pairs, 122 activities: atma 1, buddhi 2, chitta 8, vritti 18, mun 32.</a:t>
             </a:r>
           </a:p>
         </p:txBody>
@@ -12103,7 +12223,7 @@
                 </a:solidFill>
                 <a:latin typeface="Calibri"/>
               </a:rPr>
-              <a:t>KD §3.6  ·  JV pp. 92–94  ·  MVD pp. 78, 323  ·  AnalyticMadhyasthDarshan.org  ·  16 / 30</a:t>
+              <a:t>MVD pp.78,323  ·  AVD pp.91–94  ·  AnalyticMadhyasthDarshan.org  ·  16 / 30</a:t>
             </a:r>
           </a:p>
         </p:txBody>
@@ -12323,7 +12443,7 @@
                 </a:solidFill>
                 <a:latin typeface="Cambria"/>
               </a:rPr>
-              <a:t>Living on Four and a Half</a:t>
+              <a:t>Delusion and Developing Understanding</a:t>
             </a:r>
           </a:p>
         </p:txBody>
@@ -12754,7 +12874,7 @@
                 </a:solidFill>
                 <a:latin typeface="Calibri"/>
               </a:rPr>
-              <a:t>The inventory is intact</a:t>
+              <a:t>Genuine partial care is possible.</a:t>
             </a:r>
             <a:r>
               <a:rPr sz="1300" b="0" i="0">
@@ -12763,7 +12883,7 @@
                 </a:solidFill>
                 <a:latin typeface="Calibri"/>
               </a:rPr>
-              <a:t>  —  awakening changes governance, not the parts list</a:t>
+              <a:t> Its fulfilment can be understood and made dependable.</a:t>
             </a:r>
           </a:p>
         </p:txBody>
@@ -12842,7 +12962,7 @@
                 </a:solidFill>
                 <a:latin typeface="Calibri"/>
               </a:rPr>
-              <a:t>Pleasure, health, and gain stay relevant information — they simply cannot authorise an act that fails justice, dharma, or truth.</a:t>
+              <a:t>Tasting can concern sensory preference, relationship value or comprehensive human goals. Awakening gives them their appropriate direction.</a:t>
             </a:r>
           </a:p>
         </p:txBody>
@@ -12877,7 +12997,7 @@
                 </a:solidFill>
                 <a:latin typeface="Calibri"/>
               </a:rPr>
-              <a:t>JV pp. 73–74  ·  MVD pp. 66–67, 78  ·  SB pp. 91–92  ·  AnalyticMadhyasthDarshan.org  ·  17 / 30</a:t>
+              <a:t>JV printed pp.72–74  ·  MSM printed p.49  ·  PS printed pp.40–41  ·  17 / 30</a:t>
             </a:r>
           </a:p>
         </p:txBody>
@@ -14237,7 +14357,7 @@
                 </a:solidFill>
                 <a:latin typeface="Calibri"/>
               </a:rPr>
-              <a:t>Higher-conformance: mun governed from above — tasting and selection become justice-natural, and cognisance governs sensitivity. No automation: study does not force realisation, and freedom remains.</a:t>
+              <a:t>Higher-conformance carries realised understanding into tasting and selection. Inquiry, practice and evaluation develop the learner’s own understanding.</a:t>
             </a:r>
           </a:p>
         </p:txBody>
@@ -14272,7 +14392,7 @@
                 </a:solidFill>
                 <a:latin typeface="Calibri"/>
               </a:rPr>
-              <a:t>MVD pp. 126, 155–156, 208  ·  JV p. 62  ·  AnalyticMadhyasthDarshan.org  ·  18 / 30</a:t>
+              <a:t>MVD pp.126,155–156,208  ·  JV printed p.61  ·  AnalyticMadhyasthDarshan.org  ·  18 / 30</a:t>
             </a:r>
           </a:p>
         </p:txBody>
@@ -14834,7 +14954,7 @@
                 </a:solidFill>
                 <a:latin typeface="Calibri"/>
               </a:rPr>
-              <a:t>Values, character, and ethics — content that must be practised, not only stated.</a:t>
+              <a:t>Values, character and ethics understood and evidenced in practised living.</a:t>
             </a:r>
           </a:p>
         </p:txBody>
@@ -14913,7 +15033,7 @@
                 </a:solidFill>
                 <a:latin typeface="Calibri"/>
               </a:rPr>
-              <a:t>Knowing, believing, recognising, and fulfilling are four different achievements. A person may know a proposition and still not recognise the relationship in front of them — knowledge is not possession of information.</a:t>
+              <a:t>Knowing, believing, recognising and fulfilling are assessed distinctly. Understanding a principle, recognising its application and fulfilling the responsibility can develop unevenly.</a:t>
             </a:r>
           </a:p>
         </p:txBody>
@@ -15203,7 +15323,7 @@
                 </a:solidFill>
                 <a:latin typeface="Cambria"/>
               </a:rPr>
-              <a:t>One Story, Told in Order</a:t>
+              <a:t>The Connected Account</a:t>
             </a:r>
           </a:p>
         </p:txBody>
@@ -15695,7 +15815,7 @@
                 </a:solidFill>
                 <a:latin typeface="Calibri"/>
               </a:rPr>
-              <a:t>  —  the joint form: association, not fusion</a:t>
+              <a:t>  The pranic body and jeevan participate together</a:t>
             </a:r>
           </a:p>
         </p:txBody>
@@ -15809,7 +15929,7 @@
                 </a:solidFill>
                 <a:latin typeface="Calibri"/>
               </a:rPr>
-              <a:t>What must humans do that nature does not do for them?</a:t>
+              <a:t>What gives human freedom its fulfilled direction?</a:t>
             </a:r>
             <a:r>
               <a:rPr sz="1300" b="0" i="0">
@@ -15818,7 +15938,7 @@
                 </a:solidFill>
                 <a:latin typeface="Calibri"/>
               </a:rPr>
-              <a:t>  —  understand and establish order</a:t>
+              <a:t>  Understanding, evaluation and humane participation</a:t>
             </a:r>
           </a:p>
         </p:txBody>
@@ -15932,7 +16052,7 @@
                 </a:solidFill>
                 <a:latin typeface="Calibri"/>
               </a:rPr>
-              <a:t>How is understanding tested?</a:t>
+              <a:t>How does awakened living continue?</a:t>
             </a:r>
             <a:r>
               <a:rPr sz="1300" b="0" i="0">
@@ -15941,7 +16061,7 @@
                 </a:solidFill>
                 <a:latin typeface="Calibri"/>
               </a:rPr>
-              <a:t>  —  in relationship, work, and society</a:t>
+              <a:t>  Education, just relationships and maintained arrangements</a:t>
             </a:r>
           </a:p>
         </p:txBody>
@@ -16310,7 +16430,7 @@
                 </a:solidFill>
                 <a:latin typeface="Calibri"/>
               </a:rPr>
-              <a:t>Recognised and fulfilled in relationship — five families: object, jeevan, human, established, and civic values.</a:t>
+              <a:t>Thirty positions: four jeevan, six human, nine established, nine expressed, and two object values.</a:t>
             </a:r>
           </a:p>
         </p:txBody>
@@ -16617,7 +16737,7 @@
                 </a:solidFill>
                 <a:latin typeface="Calibri"/>
               </a:rPr>
-              <a:t>“Values can be tasted in work and behaviour only when relationships are accepted and recognised.”  — KD, p. 63</a:t>
+              <a:t>Realisation, thought, behaviour and work express these values in lived participation.</a:t>
             </a:r>
           </a:p>
         </p:txBody>
@@ -16652,7 +16772,7 @@
                 </a:solidFill>
                 <a:latin typeface="Calibri"/>
               </a:rPr>
-              <a:t>Where relationships are not recognised, values do not flow — mun tastes priya, hita, or labh instead.</a:t>
+              <a:t>Care can be genuinely fulfilled during learning. Its recognition, actual fulfilment and evaluation give practice concrete content.</a:t>
             </a:r>
           </a:p>
         </p:txBody>
@@ -16687,7 +16807,7 @@
                 </a:solidFill>
                 <a:latin typeface="Calibri"/>
               </a:rPr>
-              <a:t>JV pp. 54–55  ·  MVD p. 305  ·  KD pp. 63, 67  ·  AnalyticMadhyasthDarshan.org  ·  20 / 30</a:t>
+              <a:t>PS printed pp.149,151,154  ·  MSM printed p.49  ·  KD pp.63,67  ·  20 / 30</a:t>
             </a:r>
           </a:p>
         </p:txBody>
@@ -16907,7 +17027,7 @@
                 </a:solidFill>
                 <a:latin typeface="Cambria"/>
               </a:rPr>
-              <a:t>Karma, Consequence, Evaluation</a:t>
+              <a:t>A Garden: Learning and Evaluation</a:t>
             </a:r>
           </a:p>
         </p:txBody>
@@ -16942,7 +17062,7 @@
                 </a:solidFill>
                 <a:latin typeface="Calibri"/>
               </a:rPr>
-              <a:t>Karma is activity together with aspiration. Every act leaves internal, bodily, relational, and natural consequences — and a later activity can evaluate them.</a:t>
+              <a:t>A teacher, learners and caregivers grow food together. Their participation has internal, bodily, relational and natural consequences.</a:t>
             </a:r>
           </a:p>
         </p:txBody>
@@ -17021,7 +17141,7 @@
                 </a:solidFill>
                 <a:latin typeface="Cambria"/>
               </a:rPr>
-              <a:t>Deluded evaluation</a:t>
+              <a:t>Partial care</a:t>
             </a:r>
           </a:p>
         </p:txBody>
@@ -17056,7 +17176,7 @@
                 </a:solidFill>
                 <a:latin typeface="Calibri"/>
               </a:rPr>
-              <a:t>The relationship is recognised, but priya–hita–labh decide. The value goes unfulfilled; contradiction and mistrust follow.</a:t>
+              <a:t>A caregiver recognises a tired learner’s need and provides nourishment. The caring contribution is real.</a:t>
             </a:r>
           </a:p>
         </p:txBody>
@@ -17135,7 +17255,7 @@
                 </a:solidFill>
                 <a:latin typeface="Cambria"/>
               </a:rPr>
-              <a:t>Missing recognition</a:t>
+              <a:t>Understanding and means</a:t>
             </a:r>
           </a:p>
         </p:txBody>
@@ -17170,7 +17290,7 @@
                 </a:solidFill>
                 <a:latin typeface="Calibri"/>
               </a:rPr>
-              <a:t>Good intention without a recognised relationship: mun has no relationship-value to taste. The remedy is study, not repetition.</a:t>
+              <a:t>A copied task may precede understanding. Missing water, tools or assistance requires practical provision.</a:t>
             </a:r>
           </a:p>
         </p:txBody>
@@ -17249,7 +17369,7 @@
                 </a:solidFill>
                 <a:latin typeface="Cambria"/>
               </a:rPr>
-              <a:t>Fulfilled practice</a:t>
+              <a:t>Correction and continuity</a:t>
             </a:r>
           </a:p>
         </p:txBody>
@@ -17284,7 +17404,7 @@
                 </a:solidFill>
                 <a:latin typeface="Calibri"/>
               </a:rPr>
-              <a:t>Recognised relationship, karma with aspiration, value tasted, mutual satisfaction — repeated across contexts.</a:t>
+              <a:t>Participants examine learning, responsibilities, access to food and soil health, then revise the undertaking.</a:t>
             </a:r>
           </a:p>
         </p:txBody>
@@ -17319,7 +17439,7 @@
                 </a:solidFill>
                 <a:latin typeface="Calibri"/>
               </a:rPr>
-              <a:t>One act — fulfilled or failed — settles nothing by itself: evaluation links successive activities, and practice across contexts is the test.</a:t>
+              <a:t>A fulfilled act evidences a particular contribution. Continued participation across situations supports the assessment of wider understanding and conduct.</a:t>
             </a:r>
           </a:p>
         </p:txBody>
@@ -17846,7 +17966,7 @@
                 </a:solidFill>
                 <a:latin typeface="Cambria"/>
               </a:rPr>
-              <a:t>One Process, Lived Evidence</a:t>
+              <a:t>Fulfilment and Awakened Tradition</a:t>
             </a:r>
           </a:p>
         </p:txBody>
@@ -17881,7 +18001,7 @@
                 </a:solidFill>
                 <a:latin typeface="Calibri"/>
               </a:rPr>
-              <a:t>Natural orderliness and conscious establishment meet in the sixfold grammar — and are tested in living.</a:t>
+              <a:t>Realised coexistence gives direction to just relationships, useful work and the continuity of humane participation.</a:t>
             </a:r>
           </a:p>
         </p:txBody>
@@ -18329,7 +18449,7 @@
                 </a:solidFill>
                 <a:latin typeface="Calibri"/>
               </a:rPr>
-              <a:t>Every unit saturated, responsive according to its order, always active. Niyati-kram fixes which orders can become manifest.</a:t>
+              <a:t>Every unit remains saturated, responsive and active. Development has its definite order of manifestation.</a:t>
             </a:r>
           </a:p>
         </p:txBody>
@@ -18487,7 +18607,7 @@
                 </a:solidFill>
                 <a:latin typeface="Calibri"/>
               </a:rPr>
-              <a:t>Actual mutuality → recognition by conformance → one effort–motion–result → the realised result becomes the next situation.</a:t>
+              <a:t>Actual mutuality conditions complete effort, motion and result. Each outcome becomes part of further participation.</a:t>
             </a:r>
           </a:p>
         </p:txBody>
@@ -18724,7 +18844,7 @@
                 </a:solidFill>
                 <a:latin typeface="Calibri"/>
               </a:rPr>
-              <a:t>The human step adds no new engine. Recognition becomes failable, essential nature becomes refinable — answerability is what is new.</a:t>
+              <a:t>Imagination and freedom make inquiry, purposeful creation and correction possible. Awakening fulfils this capacity through comprehensive understanding.</a:t>
             </a:r>
           </a:p>
         </p:txBody>
@@ -19523,7 +19643,7 @@
                 </a:solidFill>
                 <a:latin typeface="Calibri"/>
               </a:rPr>
-              <a:t>Diagnostic pairings — questions to ask, not faculty ownership: justice, dharma, and truth work together in every comparison.</a:t>
+              <a:t>These pairings guide questions about conduct, regulation and balance. Justice, dharma and truth govern deliberation together.</a:t>
             </a:r>
           </a:p>
         </p:txBody>
@@ -20024,7 +20144,7 @@
                 </a:solidFill>
                 <a:latin typeface="Calibri"/>
               </a:rPr>
-              <a:t>Harmony of mun with vritti: selection no longer contradicts the understood purpose — happiness is resolution.</a:t>
+              <a:t>Mun with vritti: resolution and behaviour free of wrongdoing.</a:t>
             </a:r>
           </a:p>
         </p:txBody>
@@ -20270,7 +20390,7 @@
                 </a:solidFill>
                 <a:latin typeface="Calibri"/>
               </a:rPr>
-              <a:t>Harmony of vritti with chitta: comparison and contemplated meaning are coherent.</a:t>
+              <a:t>Vritti with chitta: thought free of injustice.</a:t>
             </a:r>
           </a:p>
         </p:txBody>
@@ -20516,7 +20636,7 @@
                 </a:solidFill>
                 <a:latin typeface="Calibri"/>
               </a:rPr>
-              <a:t>Harmony of chitta with buddhi: imaging and enlightened resolve agree.</a:t>
+              <a:t>Chitta with buddhi: desire free of attachment.</a:t>
             </a:r>
           </a:p>
         </p:txBody>
@@ -20762,7 +20882,7 @@
                 </a:solidFill>
                 <a:latin typeface="Calibri"/>
               </a:rPr>
-              <a:t>Harmony of buddhi with atma: resolve rests on realisation — and paramanand is realisation in coexistence itself.</a:t>
+              <a:t>Buddhi with atma: understanding free of ignorance.</a:t>
             </a:r>
           </a:p>
         </p:txBody>
@@ -20841,7 +20961,7 @@
                 </a:solidFill>
                 <a:latin typeface="Calibri"/>
               </a:rPr>
-              <a:t>Nested, not purchasable: a shortfall of happiness is a failure of concurrence within jeevan, not a shortage that objects or achievements can supply.</a:t>
+              <a:t>Paramanand is the highest human fulfilment: realisation of coexistence in continuity.</a:t>
             </a:r>
           </a:p>
         </p:txBody>
@@ -20876,7 +20996,7 @@
                 </a:solidFill>
                 <a:latin typeface="Calibri"/>
               </a:rPr>
-              <a:t>MVD pp. 100–101  ·  JV pp. 137–138  ·  AnalyticMadhyasthDarshan.org  ·  25 / 30</a:t>
+              <a:t>MVD pp.101,327  ·  MAD reader pp.47,51  ·  KD printed p.112  ·  25 / 30</a:t>
             </a:r>
           </a:p>
         </p:txBody>
@@ -21210,8 +21330,7 @@
                 </a:solidFill>
                 <a:latin typeface="Calibri"/>
               </a:rPr>
-              <a:t>The restfulness of effort: coexistence realised in atma, all three contents enlightened in buddhi, all ten activities effective, full internal harmony.
-A resolution — not a cessation of activity.</a:t>
+              <a:t>Restfulness in realised activity: coexistence realised in atma, complete knowledge enlightened in buddhi, and all ten activities effective in practised harmony.</a:t>
             </a:r>
           </a:p>
         </p:txBody>
@@ -21325,8 +21444,7 @@
                 </a:solidFill>
                 <a:latin typeface="Calibri"/>
               </a:rPr>
-              <a:t>The destination of motion: activity completeness evidenced as stable humane conduct — values, character, ethics — across relationships and work.
-Lived, repeatable, public.</a:t>
+              <a:t>Continuing humane conduct through values, character and ethics across changing relationships and work.</a:t>
             </a:r>
           </a:p>
         </p:txBody>
@@ -21405,7 +21523,7 @@
                 </a:solidFill>
                 <a:latin typeface="Calibri"/>
               </a:rPr>
-              <a:t>One fulfilled act does not establish completeness; practice across the relevant relationships and work is the operational test.</a:t>
+              <a:t>Particular fulfilment, realised activity and continuing humane conduct each call for evidence appropriate to their scope.</a:t>
             </a:r>
           </a:p>
         </p:txBody>
@@ -21440,7 +21558,7 @@
                 </a:solidFill>
                 <a:latin typeface="Calibri"/>
               </a:rPr>
-              <a:t>The jeevan whose effort has come to rest continues in effort–motion–result like every unit — what ends is unresolved striving.</a:t>
+              <a:t>Resolved jeevan continues purposeful activity and helps understanding become available to others.</a:t>
             </a:r>
           </a:p>
         </p:txBody>
@@ -22186,7 +22304,7 @@
                 </a:solidFill>
                 <a:latin typeface="Calibri"/>
               </a:rPr>
-              <a:t>are relationships recognised, values fulfilled, mutual satisfaction reached?</a:t>
+              <a:t>are relationships recognised, values fulfilled, correctly evaluated and mutually satisfying?</a:t>
             </a:r>
           </a:p>
         </p:txBody>
@@ -22449,7 +22567,7 @@
                 </a:solidFill>
                 <a:latin typeface="Calibri"/>
               </a:rPr>
-              <a:t>An organisation has no jeevan: records and procedures help, but only participating humans understand, evaluate, and establish.</a:t>
+              <a:t>Participants understand and evaluate. Shared records preserve responsibilities, contributions, decisions and correction.</a:t>
             </a:r>
           </a:p>
         </p:txBody>
@@ -22704,7 +22822,7 @@
                 </a:solidFill>
                 <a:latin typeface="Cambria"/>
               </a:rPr>
-              <a:t>Toward Undivided Society</a:t>
+              <a:t>Human Goals and Social Functions</a:t>
             </a:r>
           </a:p>
         </p:txBody>
@@ -23160,7 +23278,7 @@
                 </a:solidFill>
                 <a:latin typeface="Calibri"/>
               </a:rPr>
-              <a:t>Lived inwardly as happiness, peace, contentment, and bliss — the four goals are the public side of the same order.</a:t>
+              <a:t>Five functions sustain these goals: education–sanskar, justice–security, health–restraint, production–work, and exchange–storage.</a:t>
             </a:r>
           </a:p>
         </p:txBody>
@@ -23239,7 +23357,7 @@
                 </a:solidFill>
                 <a:latin typeface="Calibri"/>
               </a:rPr>
-              <a:t>The chain is a stated direction of evidence, not an automatic result: each scale must be maintained through recognition, value-fulfilment, regulated work, and evaluation by the humans in it.</a:t>
+              <a:t>Each function needs capable participants, appropriate means and fulfilled responsibilities. Together they sustain learning, provision and just participation.</a:t>
             </a:r>
           </a:p>
         </p:txBody>
@@ -23274,7 +23392,7 @@
                 </a:solidFill>
                 <a:latin typeface="Calibri"/>
               </a:rPr>
-              <a:t>The study stops at individual and relational evidence; deriving the social chain needs family, resource, and institutional detail (§12.7).</a:t>
+              <a:t>The garden connects teaching, care, cultivation, distribution and correction. Learners prepare to carry these responsibilities forward.</a:t>
             </a:r>
           </a:p>
         </p:txBody>
@@ -23309,7 +23427,7 @@
                 </a:solidFill>
                 <a:latin typeface="Calibri"/>
               </a:rPr>
-              <a:t>JV pp. 60–61  ·  SB pp. 246–247  ·  AnalyticMadhyasthDarshan.org  ·  28 / 30</a:t>
+              <a:t>JV printed pp.60–61,109–110,140  ·  MSM printed pp.64–65  ·  28 / 30</a:t>
             </a:r>
           </a:p>
         </p:txBody>
@@ -23494,7 +23612,7 @@
                 </a:solidFill>
                 <a:latin typeface="Calibri"/>
               </a:rPr>
-              <a:t>MOVEMENT FOUR  ·  LIMITS AS RIGOUR</a:t>
+              <a:t>MOVEMENT FOUR  ·  SHARED RESPONSIBILITY</a:t>
             </a:r>
           </a:p>
         </p:txBody>
@@ -23529,7 +23647,7 @@
                 </a:solidFill>
                 <a:latin typeface="Cambria"/>
               </a:rPr>
-              <a:t>What the Study Leaves Open</a:t>
+              <a:t>Family and Wider Coordination</a:t>
             </a:r>
           </a:p>
         </p:txBody>
@@ -23608,7 +23726,7 @@
                 </a:solidFill>
                 <a:latin typeface="Cambria"/>
               </a:rPr>
-              <a:t>Identifying jeevan physically</a:t>
+              <a:t>Family participation</a:t>
             </a:r>
           </a:p>
         </p:txBody>
@@ -23643,7 +23761,7 @@
                 </a:solidFill>
                 <a:latin typeface="Calibri"/>
               </a:rPr>
-              <a:t>No laboratory condition yet identifies constitutional completeness; the postconditions are textual.</a:t>
+              <a:t>Recognised needs and responsibilities guide useful work, care and sufficient provision.</a:t>
             </a:r>
           </a:p>
         </p:txBody>
@@ -23722,7 +23840,7 @@
                 </a:solidFill>
                 <a:latin typeface="Cambria"/>
               </a:rPr>
-              <a:t>The body–jeevan interface</a:t>
+              <a:t>Council and dialogue</a:t>
             </a:r>
           </a:p>
         </p:txBody>
@@ -23757,7 +23875,7 @@
                 </a:solidFill>
                 <a:latin typeface="Calibri"/>
               </a:rPr>
-              <a:t>The association and the faculties are stated; a physical transfer mechanism is not.</a:t>
+              <a:t>Participants deliberate, seek agreement, assign responsibilities and examine fulfilment.</a:t>
             </a:r>
           </a:p>
         </p:txBody>
@@ -23836,7 +23954,7 @@
                 </a:solidFill>
                 <a:latin typeface="Cambria"/>
               </a:rPr>
-              <a:t>No numbers</a:t>
+              <a:t>Ten-tier coordination</a:t>
             </a:r>
           </a:p>
         </p:txBody>
@@ -23871,7 +23989,7 @@
                 </a:solidFill>
                 <a:latin typeface="Calibri"/>
               </a:rPr>
-              <a:t>Strength, harmony, and value stay qualitative — no common scale spans atoms, bodies, and realisation.</a:t>
+              <a:t>Family councils connect through wider councils toward the world family.</a:t>
             </a:r>
           </a:p>
         </p:txBody>
@@ -23950,7 +24068,7 @@
                 </a:solidFill>
                 <a:latin typeface="Cambria"/>
               </a:rPr>
-              <a:t>Social-scale dynamics</a:t>
+              <a:t>Humane constitution</a:t>
             </a:r>
           </a:p>
         </p:txBody>
@@ -23985,7 +24103,7 @@
                 </a:solidFill>
                 <a:latin typeface="Calibri"/>
               </a:rPr>
-              <a:t>The path from family to undivided society is a stated direction, not a derived result.</a:t>
+              <a:t>Shared values, character and ethics guide education, responsibilities and maintained arrangements.</a:t>
             </a:r>
           </a:p>
         </p:txBody>
@@ -24064,7 +24182,7 @@
                 </a:solidFill>
                 <a:latin typeface="Calibri"/>
               </a:rPr>
-              <a:t>Stating these limits is part of the study’s method: practitioners should not claim more than the texts and the evidence carry.</a:t>
+              <a:t>Samvidhan gives humane conduct a shared social form. Families and councils carry it into continuing participation.</a:t>
             </a:r>
           </a:p>
         </p:txBody>
@@ -24099,7 +24217,7 @@
                 </a:solidFill>
                 <a:latin typeface="Calibri"/>
               </a:rPr>
-              <a:t>Study §12  ·  AnalyticMadhyasthDarshan.org  ·  29 / 30</a:t>
+              <a:t>MVD pp.18–19,161,253  ·  JVD PDF pp.237–238,249–328  ·  29 / 30</a:t>
             </a:r>
           </a:p>
         </p:txBody>
@@ -24626,7 +24744,7 @@
                 </a:solidFill>
                 <a:latin typeface="Calibri"/>
               </a:rPr>
-              <a:t>Nothing in existence has to be started. Every unit is soaked in Omnipresence and is already one complete activity.</a:t>
+              <a:t>Units saturated in Omnipresence are continuously active in mutuality. Form, property, essential nature and dharma describe each unit.</a:t>
             </a:r>
           </a:p>
         </p:txBody>
@@ -24881,7 +24999,7 @@
                 </a:solidFill>
                 <a:latin typeface="Calibri"/>
               </a:rPr>
-              <a:t>CLOSE  ·  THE WHOLE IN SIX STEPS</a:t>
+              <a:t>CLOSE  ·  AWAKENED TRADITION</a:t>
             </a:r>
           </a:p>
         </p:txBody>
@@ -24916,7 +25034,7 @@
                 </a:solidFill>
                 <a:latin typeface="Cambria"/>
               </a:rPr>
-              <a:t>The One Governing Story</a:t>
+              <a:t>Continuity of Awakened Living</a:t>
             </a:r>
           </a:p>
         </p:txBody>
@@ -25030,7 +25148,7 @@
                 </a:solidFill>
                 <a:latin typeface="Calibri"/>
               </a:rPr>
-              <a:t>State-complete satta coexists with saturated, state-dynamic units</a:t>
+              <a:t>Realised coexistence fulfils jeevan as paramanand</a:t>
             </a:r>
           </a:p>
         </p:txBody>
@@ -25144,7 +25262,7 @@
                 </a:solidFill>
                 <a:latin typeface="Calibri"/>
               </a:rPr>
-              <a:t>Each unit is one effort–motion–result</a:t>
+              <a:t>Humane conduct expresses understanding:</a:t>
             </a:r>
             <a:r>
               <a:rPr sz="1300" b="0" i="0">
@@ -25153,7 +25271,7 @@
                 </a:solidFill>
                 <a:latin typeface="Calibri"/>
               </a:rPr>
-              <a:t>  —  read as form, property, essential nature, dharma</a:t>
+              <a:t> values, character and ethics in living.</a:t>
             </a:r>
           </a:p>
         </p:txBody>
@@ -25267,7 +25385,7 @@
                 </a:solidFill>
                 <a:latin typeface="Calibri"/>
               </a:rPr>
-              <a:t>Mutuality and mediative activity make natural orderliness evident</a:t>
+              <a:t>Five functions sustain provision and mutual fulfilment</a:t>
             </a:r>
           </a:p>
         </p:txBody>
@@ -25381,7 +25499,7 @@
                 </a:solidFill>
                 <a:latin typeface="Calibri"/>
               </a:rPr>
-              <a:t>Closures build bodies; one atomic line yields jeevan</a:t>
+              <a:t>Humane constitution guides shared responsibilities.</a:t>
             </a:r>
             <a:r>
               <a:rPr sz="1300" b="0" i="0">
@@ -25390,7 +25508,7 @@
                 </a:solidFill>
                 <a:latin typeface="Calibri"/>
               </a:rPr>
-              <a:t>  —  joint forms manifest animal and human orders</a:t>
+              <a:t> Councils coordinate toward the world family.</a:t>
             </a:r>
           </a:p>
         </p:txBody>
@@ -25504,7 +25622,7 @@
                 </a:solidFill>
                 <a:latin typeface="Calibri"/>
               </a:rPr>
-              <a:t>The human threshold makes recognition and fulfilment answerable</a:t>
+              <a:t>Education prepares later participants.</a:t>
             </a:r>
             <a:r>
               <a:rPr sz="1300" b="0" i="0">
@@ -25513,7 +25631,7 @@
                 </a:solidFill>
                 <a:latin typeface="Calibri"/>
               </a:rPr>
-              <a:t>  —  and failable</a:t>
+              <a:t> Inquiry and practice develop independent responsibility.</a:t>
             </a:r>
           </a:p>
         </p:txBody>
@@ -25627,7 +25745,7 @@
                 </a:solidFill>
                 <a:latin typeface="Calibri"/>
               </a:rPr>
-              <a:t>Realised knowledge makes satya–dharma–nyaya effective</a:t>
+              <a:t>Awakened tradition continues across generations:</a:t>
             </a:r>
             <a:r>
               <a:rPr sz="1300" b="0" i="0">
@@ -25636,7 +25754,7 @@
                 </a:solidFill>
                 <a:latin typeface="Calibri"/>
               </a:rPr>
-              <a:t>  —  in thought, relationship, work, society</a:t>
+              <a:t> undivided society and universal orderliness.</a:t>
             </a:r>
           </a:p>
         </p:txBody>
@@ -25891,7 +26009,7 @@
                 </a:solidFill>
                 <a:latin typeface="Cambria"/>
               </a:rPr>
-              <a:t>Two Inseparable Presences</a:t>
+              <a:t>Satta and Active Units</a:t>
             </a:r>
           </a:p>
         </p:txBody>
@@ -26347,7 +26465,7 @@
                 </a:solidFill>
                 <a:latin typeface="Cambria"/>
               </a:rPr>
-              <a:t>No push, no transfer</a:t>
+              <a:t>The unit’s strength</a:t>
             </a:r>
           </a:p>
         </p:txBody>
@@ -26382,7 +26500,7 @@
                 </a:solidFill>
                 <a:latin typeface="Calibri"/>
               </a:rPr>
-              <a:t>Satta does not act on units. The strength at work in any change belongs to the saturated unit itself.</a:t>
+              <a:t>Saturation grounds the unit’s energy-fullness. Its own strength and power are effective in mutuality.</a:t>
             </a:r>
           </a:p>
         </p:txBody>
@@ -26637,7 +26755,7 @@
                 </a:solidFill>
                 <a:latin typeface="Cambria"/>
               </a:rPr>
-              <a:t>A Unit Is One Activity</a:t>
+              <a:t>The Unit and Its Activity</a:t>
             </a:r>
           </a:p>
         </p:txBody>
@@ -26672,7 +26790,7 @@
                 </a:solidFill>
                 <a:latin typeface="Calibri"/>
               </a:rPr>
-              <a:t>A unit is not a thing that also happens to act. It is a bounded activity that persists — an atom, a molecule, a cell, a body.</a:t>
+              <a:t>A unit persists as an active bearer. Its effort, motion and result are inseparable in every participation.</a:t>
             </a:r>
           </a:p>
         </p:txBody>
@@ -27014,7 +27132,7 @@
                 </a:solidFill>
                 <a:latin typeface="Calibri"/>
               </a:rPr>
-              <a:t>The three are co-present aspects of one activity — not three stages with pauses between them.</a:t>
+              <a:t>Effort, motion and result are co-present aspects of complete activity.</a:t>
             </a:r>
           </a:p>
         </p:txBody>
@@ -27128,7 +27246,7 @@
                 </a:solidFill>
                 <a:latin typeface="Calibri"/>
               </a:rPr>
-              <a:t>No leftover carrier underneath: once effort, motion, and result are named, nothing remains to be moved. The result of one occurrence is already the state of the next.</a:t>
+              <a:t>Guni names the active bearer; guna names its relative power in mutuality. A result becomes part of the conditions for further activity.</a:t>
             </a:r>
           </a:p>
         </p:txBody>
@@ -27383,7 +27501,7 @@
                 </a:solidFill>
                 <a:latin typeface="Cambria"/>
               </a:rPr>
-              <a:t>The Same Activity, Read Two Ways</a:t>
+              <a:t>Four Aspects of an Active Unit</a:t>
             </a:r>
           </a:p>
         </p:txBody>
@@ -27497,7 +27615,7 @@
                 </a:solidFill>
                 <a:latin typeface="Calibri"/>
               </a:rPr>
-              <a:t>The bounded configuration — shape, volume, density. The result side of the activity, reflected and met in mutuality.</a:t>
+              <a:t>The unit’s determinate configuration, including shape, volume and density, encountered in mutuality.</a:t>
             </a:r>
           </a:p>
         </p:txBody>
@@ -27725,7 +27843,7 @@
                 </a:solidFill>
                 <a:latin typeface="Calibri"/>
               </a:rPr>
-              <a:t>The order-specific way strength and power function — integrating, vitalising, cruel or non-cruel, humane or opposing.</a:t>
+              <a:t>Its characteristic conduct and functional significance in participation: integrating, vitalising or humane, for example.</a:t>
             </a:r>
           </a:p>
         </p:txBody>
@@ -27839,7 +27957,7 @@
                 </a:solidFill>
                 <a:latin typeface="Calibri"/>
               </a:rPr>
-              <a:t>Innateness (dharana): what cannot be separated from a unit of that order — what its fulfilment means. Not an added force.</a:t>
+              <a:t>Innateness: what the unit bears inseparably and what its fulfilment means.</a:t>
             </a:r>
           </a:p>
         </p:txBody>
@@ -27918,7 +28036,7 @@
                 </a:solidFill>
                 <a:latin typeface="Calibri"/>
               </a:rPr>
-              <a:t>Effort is borne as dharma–svabhav, motion as svabhav–guna, result as roop (SB pp. 60–62). The triad says how the activity runs; the tetrad says what it is an activity of.</a:t>
+              <a:t>The active unit bears these four aspects. Effort, motion and result describe its activity through their connected expression.</a:t>
             </a:r>
           </a:p>
         </p:txBody>
@@ -28173,7 +28291,7 @@
                 </a:solidFill>
                 <a:latin typeface="Cambria"/>
               </a:rPr>
-              <a:t>Nothing Acts Alone</a:t>
+              <a:t>Activity in Mutuality</a:t>
             </a:r>
           </a:p>
         </p:txBody>
@@ -28340,7 +28458,7 @@
                 </a:solidFill>
                 <a:latin typeface="Calibri"/>
               </a:rPr>
-              <a:t>Complementarity is evidenced in offering, acceptance, and fulfilment</a:t>
+              <a:t>Complementary participation sustains mutual fulfilment</a:t>
             </a:r>
             <a:r>
               <a:rPr sz="1300" b="0" i="0">
@@ -28349,7 +28467,7 @@
                 </a:solidFill>
                 <a:latin typeface="Calibri"/>
               </a:rPr>
-              <a:t>  —  not in conflict</a:t>
+              <a:t> through offering and acceptance.</a:t>
             </a:r>
           </a:p>
         </p:txBody>
@@ -28516,7 +28634,7 @@
                 </a:solidFill>
                 <a:latin typeface="Calibri"/>
               </a:rPr>
-              <a:t>Each realised result is written into the situation neighbours face next</a:t>
+              <a:t>Each realised result conditions further participation</a:t>
             </a:r>
             <a:r>
               <a:rPr sz="1300" b="0" i="0">
@@ -28525,7 +28643,7 @@
                 </a:solidFill>
                 <a:latin typeface="Calibri"/>
               </a:rPr>
-              <a:t>  —  a running loop</a:t>
+              <a:t> in the situation the units now face.</a:t>
             </a:r>
           </a:p>
         </p:txBody>
@@ -28604,7 +28722,7 @@
                 </a:solidFill>
                 <a:latin typeface="Calibri"/>
               </a:rPr>
-              <a:t>Law, regulation, and balance are grounded here</a:t>
+              <a:t>Law, regulation and balance have natural expression</a:t>
             </a:r>
             <a:r>
               <a:rPr sz="1300" b="0" i="0">
@@ -28613,7 +28731,7 @@
                 </a:solidFill>
                 <a:latin typeface="Calibri"/>
               </a:rPr>
-              <a:t>  —  niyam–niyantran–santulan, not decrees</a:t>
+              <a:t> as niyam, niyantran and santulan.</a:t>
             </a:r>
           </a:p>
         </p:txBody>
@@ -29254,7 +29372,7 @@
                 </a:solidFill>
                 <a:latin typeface="Calibri"/>
               </a:rPr>
-              <a:t>How closures build molecules, cells, and bodies — and how one distinct atomic line yields jeevan.</a:t>
+              <a:t>Material composition forms molecules, cells and bodies. Atomic development reaches constitutional completeness as jeevan.</a:t>
             </a:r>
           </a:p>
         </p:txBody>

</xml_diff>

<commit_message>
Update JVD translation reference and sync all citations across studies and Primer
</commit_message>
<xml_diff>
--- a/Studies/A-State-Dynamic-Model-Of-Coexistence/A-State-Dynamic-Model-Of-Coexistence-Madhyasth-Darshan.pptx
+++ b/Studies/A-State-Dynamic-Model-Of-Coexistence/A-State-Dynamic-Model-Of-Coexistence-Madhyasth-Darshan.pptx
@@ -2441,7 +2441,7 @@
           </a:p>
           <a:p>
             <a:r>
-              <a:t>- MVD pp.18–19,161,253; JVD PDF pp.237–238,249–328; JV printed p.126</a:t>
+              <a:t>- MVD pp.18–19,161,253; JVD PDF pp.175,179–225; JV printed p.126</a:t>
             </a:r>
           </a:p>
         </p:txBody>
@@ -24217,7 +24217,7 @@
                 </a:solidFill>
                 <a:latin typeface="Calibri"/>
               </a:rPr>
-              <a:t>MVD pp.18–19,161,253  ·  JVD PDF pp.237–238,249–328  ·  29 / 30</a:t>
+              <a:t>MVD pp.18–19,161,253  ·  JVD PDF pp.175,179–225  ·  29 / 30</a:t>
             </a:r>
           </a:p>
         </p:txBody>

</xml_diff>